<commit_message>
Clean public hygiene and deck artifacts
Sanitize absolute macOS home paths out of the tracked slide-deck
validation JSON so LOCAL-PATH-002 stops failing public-hygiene CI.
Strip trailing whitespace from the final SVGs, make scripts/check.sh
executable, promote the 15-slide export to the canonical deck, and drop
the generated svg_output backups (canonical copies remain in svg_output/
and svg_final/). Adds a .gitignore rule to keep backups out.

Co-Authored-By: Claude <noreply@anthropic.com>
</commit_message>
<xml_diff>
--- a/Slide Deck/Axiom-PMO-Overview.pptx
+++ b/Slide Deck/Axiom-PMO-Overview.pptx
@@ -4,6 +4,9 @@
   <p:sldMasterIdLst>
     <p:sldMasterId id="2147483648" r:id="rId1"/>
   </p:sldMasterIdLst>
+  <p:notesMasterIdLst>
+    <p:notesMasterId r:id="rId22"/>
+  </p:notesMasterIdLst>
   <p:sldIdLst>
     <p:sldId id="256" r:id="rId7"/>
     <p:sldId id="257" r:id="rId8"/>
@@ -19,6 +22,7 @@
     <p:sldId id="267" r:id="rId18"/>
     <p:sldId id="268" r:id="rId19"/>
     <p:sldId id="269" r:id="rId20"/>
+    <p:sldId id="270" r:id="rId21"/>
   </p:sldIdLst>
   <p:sldSz cx="12192000" cy="6858000" type="screen4x3"/>
   <p:notesSz cx="6858000" cy="9144000"/>
@@ -118,6 +122,2326 @@
     </a:lvl9pPr>
   </p:defaultTextStyle>
 </p:presentation>
+</file>
+
+<file path=ppt/notesMasters/notesMaster1.xml><?xml version="1.0" encoding="utf-8"?>
+<p:notesMaster xmlns:a="http://schemas.openxmlformats.org/drawingml/2006/main" xmlns:r="http://schemas.openxmlformats.org/officeDocument/2006/relationships" xmlns:p="http://schemas.openxmlformats.org/presentationml/2006/main">
+  <p:cSld>
+    <p:spTree>
+      <p:nvGrpSpPr>
+        <p:cNvPr id="1" name=""/>
+        <p:cNvGrpSpPr/>
+        <p:nvPr/>
+      </p:nvGrpSpPr>
+      <p:grpSpPr>
+        <a:xfrm>
+          <a:off x="0" y="0"/>
+          <a:ext cx="0" cy="0"/>
+          <a:chOff x="0" y="0"/>
+          <a:chExt cx="0" cy="0"/>
+        </a:xfrm>
+      </p:grpSpPr>
+      <p:sp>
+        <p:nvSpPr>
+          <p:cNvPr id="2" name="Header Placeholder 1"/>
+          <p:cNvSpPr>
+            <a:spLocks noGrp="1"/>
+          </p:cNvSpPr>
+          <p:nvPr>
+            <p:ph type="hdr" sz="quarter"/>
+          </p:nvPr>
+        </p:nvSpPr>
+        <p:spPr>
+          <a:xfrm>
+            <a:off x="0" y="0"/>
+            <a:ext cx="2971800" cy="457200"/>
+          </a:xfrm>
+          <a:prstGeom prst="rect">
+            <a:avLst/>
+          </a:prstGeom>
+        </p:spPr>
+        <p:txBody>
+          <a:bodyPr/>
+          <a:lstStyle/>
+          <a:p>
+            <a:endParaRPr lang="en-US"/>
+          </a:p>
+        </p:txBody>
+      </p:sp>
+      <p:sp>
+        <p:nvSpPr>
+          <p:cNvPr id="3" name="Date Placeholder 2"/>
+          <p:cNvSpPr>
+            <a:spLocks noGrp="1"/>
+          </p:cNvSpPr>
+          <p:nvPr>
+            <p:ph type="dt" sz="half" idx="1"/>
+          </p:nvPr>
+        </p:nvSpPr>
+        <p:spPr>
+          <a:xfrm>
+            <a:off x="3884613" y="0"/>
+            <a:ext cx="2971800" cy="457200"/>
+          </a:xfrm>
+          <a:prstGeom prst="rect">
+            <a:avLst/>
+          </a:prstGeom>
+        </p:spPr>
+        <p:txBody>
+          <a:bodyPr/>
+          <a:lstStyle/>
+          <a:p>
+            <a:endParaRPr lang="en-US"/>
+          </a:p>
+        </p:txBody>
+      </p:sp>
+      <p:sp>
+        <p:nvSpPr>
+          <p:cNvPr id="4" name="Slide Image Placeholder 3"/>
+          <p:cNvSpPr>
+            <a:spLocks noGrp="1" noRot="1" noChangeAspect="1"/>
+          </p:cNvSpPr>
+          <p:nvPr>
+            <p:ph type="sldImg" idx="2"/>
+          </p:nvPr>
+        </p:nvSpPr>
+        <p:spPr>
+          <a:xfrm>
+            <a:off x="1143000" y="685800"/>
+            <a:ext cx="4572000" cy="3429000"/>
+          </a:xfrm>
+          <a:prstGeom prst="rect">
+            <a:avLst/>
+          </a:prstGeom>
+        </p:spPr>
+      </p:sp>
+      <p:sp>
+        <p:nvSpPr>
+          <p:cNvPr id="5" name="Notes Placeholder 4"/>
+          <p:cNvSpPr>
+            <a:spLocks noGrp="1"/>
+          </p:cNvSpPr>
+          <p:nvPr>
+            <p:ph type="body" sz="quarter" idx="3"/>
+          </p:nvPr>
+        </p:nvSpPr>
+        <p:spPr>
+          <a:xfrm>
+            <a:off x="685800" y="4343400"/>
+            <a:ext cx="5486400" cy="4114800"/>
+          </a:xfrm>
+          <a:prstGeom prst="rect">
+            <a:avLst/>
+          </a:prstGeom>
+        </p:spPr>
+        <p:txBody>
+          <a:bodyPr/>
+          <a:lstStyle/>
+          <a:p>
+            <a:endParaRPr lang="en-US"/>
+          </a:p>
+        </p:txBody>
+      </p:sp>
+      <p:sp>
+        <p:nvSpPr>
+          <p:cNvPr id="6" name="Footer Placeholder 5"/>
+          <p:cNvSpPr>
+            <a:spLocks noGrp="1"/>
+          </p:cNvSpPr>
+          <p:nvPr>
+            <p:ph type="ftr" sz="quarter" idx="4"/>
+          </p:nvPr>
+        </p:nvSpPr>
+        <p:spPr>
+          <a:xfrm>
+            <a:off x="0" y="8685213"/>
+            <a:ext cx="2971800" cy="457200"/>
+          </a:xfrm>
+          <a:prstGeom prst="rect">
+            <a:avLst/>
+          </a:prstGeom>
+        </p:spPr>
+        <p:txBody>
+          <a:bodyPr/>
+          <a:lstStyle/>
+          <a:p>
+            <a:endParaRPr lang="en-US"/>
+          </a:p>
+        </p:txBody>
+      </p:sp>
+      <p:sp>
+        <p:nvSpPr>
+          <p:cNvPr id="7" name="Slide Number Placeholder 6"/>
+          <p:cNvSpPr>
+            <a:spLocks noGrp="1"/>
+          </p:cNvSpPr>
+          <p:nvPr>
+            <p:ph type="sldNum" sz="quarter" idx="5"/>
+          </p:nvPr>
+        </p:nvSpPr>
+        <p:spPr>
+          <a:xfrm>
+            <a:off x="3884613" y="8685213"/>
+            <a:ext cx="2971800" cy="457200"/>
+          </a:xfrm>
+          <a:prstGeom prst="rect">
+            <a:avLst/>
+          </a:prstGeom>
+        </p:spPr>
+        <p:txBody>
+          <a:bodyPr/>
+          <a:lstStyle/>
+          <a:p>
+            <a:endParaRPr lang="en-US"/>
+          </a:p>
+        </p:txBody>
+      </p:sp>
+    </p:spTree>
+  </p:cSld>
+  <p:clrMap bg1="lt1" tx1="dk1" bg2="lt2" tx2="dk2" accent1="accent1" accent2="accent2" accent3="accent3" accent4="accent4" accent5="accent5" accent6="accent6" hlink="hlink" folHlink="folHlink"/>
+  <p:hf/>
+  <p:notesStyle>
+    <a:lvl1pPr marL="0" algn="l">
+      <a:defRPr sz="1200" lang="en-US"/>
+    </a:lvl1pPr>
+  </p:notesStyle>
+</p:notesMaster>
+</file>
+
+<file path=ppt/notesSlides/notesSlide1.xml><?xml version="1.0" encoding="utf-8"?>
+<p:notes xmlns:a="http://schemas.openxmlformats.org/drawingml/2006/main" xmlns:r="http://schemas.openxmlformats.org/officeDocument/2006/relationships" xmlns:p="http://schemas.openxmlformats.org/presentationml/2006/main">
+  <p:cSld>
+    <p:spTree>
+      <p:nvGrpSpPr>
+        <p:cNvPr id="1" name=""/>
+        <p:cNvGrpSpPr/>
+        <p:nvPr/>
+      </p:nvGrpSpPr>
+      <p:grpSpPr>
+        <a:xfrm>
+          <a:off x="0" y="0"/>
+          <a:ext cx="0" cy="0"/>
+          <a:chOff x="0" y="0"/>
+          <a:chExt cx="0" cy="0"/>
+        </a:xfrm>
+      </p:grpSpPr>
+      <p:sp>
+        <p:nvSpPr>
+          <p:cNvPr id="2" name="Slide Image Placeholder 1"/>
+          <p:cNvSpPr>
+            <a:spLocks noGrp="1" noRot="1" noChangeAspect="1"/>
+          </p:cNvSpPr>
+          <p:nvPr>
+            <p:ph type="sldImg" idx="2"/>
+          </p:nvPr>
+        </p:nvSpPr>
+        <p:spPr/>
+      </p:sp>
+      <p:sp>
+        <p:nvSpPr>
+          <p:cNvPr id="3" name="Notes Placeholder 2"/>
+          <p:cNvSpPr>
+            <a:spLocks noGrp="1"/>
+          </p:cNvSpPr>
+          <p:nvPr>
+            <p:ph type="body" sz="quarter" idx="3"/>
+          </p:nvPr>
+        </p:nvSpPr>
+        <p:spPr/>
+        <p:txBody>
+          <a:bodyPr/>
+          <a:lstStyle/>
+          <a:p>
+            <a:r>
+              <a:rPr lang="en-US" dirty="0"/>
+              <a:t>01_cover</a:t>
+            </a:r>
+          </a:p>
+          <a:p>
+            <a:endParaRPr lang="en-US" dirty="0"/>
+          </a:p>
+          <a:p>
+            <a:r>
+              <a:rPr lang="en-US" dirty="0"/>
+              <a:t>[เปิดเรื่อง]</a:t>
+            </a:r>
+          </a:p>
+          <a:p>
+            <a:r>
+              <a:rPr lang="en-US" dirty="0"/>
+              <a:t>สวัสดีครับทุกท่าน วันนี้เราจะมาคุยกันเรื่องสำคัญที่คนใช้ AI ช่วยทำงานต้องเจอ คือเรื่อง "ความน่าเชื่อถือ" ของงานที่ AI ส่งมาครับ</a:t>
+            </a:r>
+          </a:p>
+          <a:p>
+            <a:endParaRPr lang="en-US" dirty="0"/>
+          </a:p>
+          <a:p>
+            <a:r>
+              <a:rPr lang="en-US" dirty="0"/>
+              <a:t>[ขยายความ]</a:t>
+            </a:r>
+          </a:p>
+          <a:p>
+            <a:r>
+              <a:rPr lang="en-US" dirty="0"/>
+              <a:t>อย่างที่โปรยไว้บนหน้าจอเลยครับ "AI agents can write code. They should not invent the project." ทุกวันนี้เรายอมรับกันแล้วว่า AI เขียนโค้ดเก่งมาก แต่ปัญหาที่เราเจอคือ บางครั้งมันไม่ได้แค่เขียนโค้ด แต่มันดัน "กุ" หรือแต่งโปรเจกต์ขึ้นมาเองด้วย เด็คนี้เราเลยจะมาว่าด้วยเส้นแบ่งระหว่างคำว่า "AI ทำงานให้เราได้" กับ "AI กำลังตัดสินใจแทนเรา" ซึ่งเป็นเส้นที่ข้ามไม่ได้ครับ</a:t>
+            </a:r>
+          </a:p>
+          <a:p>
+            <a:endParaRPr lang="en-US" dirty="0"/>
+          </a:p>
+          <a:p>
+            <a:r>
+              <a:rPr lang="en-US" dirty="0"/>
+              <a:t>[คำถามที่อาจพบ &amp; สำหรับสายเทคนิค]</a:t>
+            </a:r>
+          </a:p>
+          <a:p>
+            <a:r>
+              <a:rPr lang="en-US" dirty="0"/>
+              <a:t>ถ้ามีคนถามว่าเฟรมเวิร์กนี้มาแทน CI/CD หรือเปล่า? คำตอบคือไม่ใช่ครับ Axiom-PMO (รุ่น 1.1.1) เป็นเฟรมเวิร์กสำหรับ "กำกับการทำงาน" (Anti-Hallucination Framework) ที่ครอบอยู่บนกระบวนการพัฒนาซอฟต์แวร์อีกที เพื่อป้องกันไม่ให้ AI แทรกแซงในส่วนที่ต้องใช้การตัดสินใจของมนุษย์</a:t>
+            </a:r>
+          </a:p>
+          <a:p>
+            <a:endParaRPr lang="en-US" dirty="0"/>
+          </a:p>
+          <a:p>
+            <a:r>
+              <a:rPr lang="en-US" dirty="0"/>
+              <a:t>[ส่งเข้าหน้าถัดไป]</a:t>
+            </a:r>
+          </a:p>
+          <a:p>
+            <a:r>
+              <a:rPr lang="en-US" dirty="0"/>
+              <a:t>แล้วทำไมเราถึงต้องจริงจังกับเรื่องนี้ขนาดที่ต้องมี Framework มาครอบ? ปัญหาที่แท้จริงหน้าตาเป็นยังไง? เดี๋ยวเราไปดูในหน้าถัดไปกันครับ</a:t>
+            </a:r>
+          </a:p>
+        </p:txBody>
+      </p:sp>
+    </p:spTree>
+  </p:cSld>
+  <p:clrMapOvr>
+    <a:masterClrMapping/>
+  </p:clrMapOvr>
+</p:notes>
+</file>
+
+<file path=ppt/notesSlides/notesSlide10.xml><?xml version="1.0" encoding="utf-8"?>
+<p:notes xmlns:a="http://schemas.openxmlformats.org/drawingml/2006/main" xmlns:r="http://schemas.openxmlformats.org/officeDocument/2006/relationships" xmlns:p="http://schemas.openxmlformats.org/presentationml/2006/main">
+  <p:cSld>
+    <p:spTree>
+      <p:nvGrpSpPr>
+        <p:cNvPr id="1" name=""/>
+        <p:cNvGrpSpPr/>
+        <p:nvPr/>
+      </p:nvGrpSpPr>
+      <p:grpSpPr>
+        <a:xfrm>
+          <a:off x="0" y="0"/>
+          <a:ext cx="0" cy="0"/>
+          <a:chOff x="0" y="0"/>
+          <a:chExt cx="0" cy="0"/>
+        </a:xfrm>
+      </p:grpSpPr>
+      <p:sp>
+        <p:nvSpPr>
+          <p:cNvPr id="2" name="Slide Image Placeholder 1"/>
+          <p:cNvSpPr>
+            <a:spLocks noGrp="1" noRot="1" noChangeAspect="1"/>
+          </p:cNvSpPr>
+          <p:nvPr>
+            <p:ph type="sldImg" idx="2"/>
+          </p:nvPr>
+        </p:nvSpPr>
+        <p:spPr/>
+      </p:sp>
+      <p:sp>
+        <p:nvSpPr>
+          <p:cNvPr id="3" name="Notes Placeholder 2"/>
+          <p:cNvSpPr>
+            <a:spLocks noGrp="1"/>
+          </p:cNvSpPr>
+          <p:nvPr>
+            <p:ph type="body" sz="quarter" idx="3"/>
+          </p:nvPr>
+        </p:nvSpPr>
+        <p:spPr/>
+        <p:txBody>
+          <a:bodyPr/>
+          <a:lstStyle/>
+          <a:p>
+            <a:r>
+              <a:rPr lang="en-US" dirty="0"/>
+              <a:t>10_why_handoff</a:t>
+            </a:r>
+          </a:p>
+          <a:p>
+            <a:endParaRPr lang="en-US" dirty="0"/>
+          </a:p>
+          <a:p>
+            <a:r>
+              <a:rPr lang="en-US" dirty="0"/>
+              <a:t>[เปิดเรื่อง]</a:t>
+            </a:r>
+          </a:p>
+          <a:p>
+            <a:r>
+              <a:rPr lang="en-US" dirty="0"/>
+              <a:t>มาเจาะลึกกันเรื่องด่าน Handoff ครับ ทำไมถึงต้องมีด่านนี้แยกออกมาต่างหาก? ทั้งๆ ที่เอกสารครบทุกช่องแล้วก็น่าจะส่งให้ Dev ทำต่อได้เลยนี่นา</a:t>
+            </a:r>
+          </a:p>
+          <a:p>
+            <a:endParaRPr lang="en-US" dirty="0"/>
+          </a:p>
+          <a:p>
+            <a:r>
+              <a:rPr lang="en-US" dirty="0"/>
+              <a:t>[ขยายความ]</a:t>
+            </a:r>
+          </a:p>
+          <a:p>
+            <a:r>
+              <a:rPr lang="en-US" dirty="0"/>
+              <a:t>[สำหรับผู้บริหาร]: บางครั้งการที่ทีมงานกรอกแบบฟอร์มครบทุกช่อง ไม่ได้แปลว่างานนั้นจะลงมือทำได้จริงนะครับ เรามักจะพบว่า พอส่งงานให้ Dev ไปแล้ว Dev กลับต้องเสียเวลาไปกับการแก้ปัญหาพื้นฐาน เช่น รันโค้ดไม่ขึ้น หรือระบบไม่รองรับ ซึ่งปัญหาแต่ละเคส ทำให้เราเสียเวลาทำงานของทีมไปเป็นวันๆ เลยครับ</a:t>
+            </a:r>
+          </a:p>
+          <a:p>
+            <a:r>
+              <a:rPr lang="en-US" dirty="0"/>
+              <a:t>[สำหรับทีมเทคนิค]: ลองดู 5 เคสตัวอย่างนี้ครับ เช่น การเรียงลำดับ Build ผิด เอา Schema กลางไปไว้หลังสุด วิศวกรสองคนก็นั่งงมไปทั้งวัน หรือทำฟีเจอร์กล้อง แต่ไม่มีการคุยเรื่อง Environment ว่าจะ Serve แบบ HTTPS ยังไง พอมารันบนแท็บเล็ตก็พัง</a:t>
+            </a:r>
+          </a:p>
+          <a:p>
+            <a:endParaRPr lang="en-US" dirty="0"/>
+          </a:p>
+          <a:p>
+            <a:r>
+              <a:rPr lang="en-US" dirty="0"/>
+              <a:t>ปัญหาก็คือ กฎทั่วๆ ไปที่เช็คแค่ว่า "ช่องนี้กรอกข้อมูลหรือยัง" จะมองไม่เห็นความพัง 5 แบบนี้เลยครับ มันเลยเป็นเหตุผลที่เราต้องมีด่าน Handoff ที่ฉลาดกว่านั้น</a:t>
+            </a:r>
+          </a:p>
+          <a:p>
+            <a:endParaRPr lang="en-US" dirty="0"/>
+          </a:p>
+          <a:p>
+            <a:r>
+              <a:rPr lang="en-US" dirty="0"/>
+              <a:t>[คำถามที่อาจพบ &amp; สำหรับสายเทคนิค]</a:t>
+            </a:r>
+          </a:p>
+          <a:p>
+            <a:r>
+              <a:rPr lang="en-US" dirty="0"/>
+              <a:t>กฎของ Axiom-PMO ในด่านนี้จึงไม่ได้แค่ตรวจ Syntax แต่ตรวจ Dependency Tree ว่าเรียงลำดับถูกไหม มี Seed data จริงๆ ให้เทสต์ครอบคลุมหรือเปล่า ซึ่งถ้าปล่อยผ่านไป มันจะไปบรรลัยในเช้าวันจันทร์ตอนเริ่ม Sprint แน่นอน</a:t>
+            </a:r>
+          </a:p>
+          <a:p>
+            <a:endParaRPr lang="en-US" dirty="0"/>
+          </a:p>
+          <a:p>
+            <a:r>
+              <a:rPr lang="en-US" dirty="0"/>
+              <a:t>[ส่งเข้าหน้าถัดไป]</a:t>
+            </a:r>
+          </a:p>
+          <a:p>
+            <a:r>
+              <a:rPr lang="en-US" dirty="0"/>
+              <a:t>แล้ว Validator ของด่าน Handoff มันทำงานยังไงให้ฉลาดขึ้นโดยที่ไม่มั่ว? เราใช้เทคนิคการแบ่งการตรวจสอบออกเป็น 2 ชั้นครับ</a:t>
+            </a:r>
+          </a:p>
+        </p:txBody>
+      </p:sp>
+    </p:spTree>
+  </p:cSld>
+  <p:clrMapOvr>
+    <a:masterClrMapping/>
+  </p:clrMapOvr>
+</p:notes>
+</file>
+
+<file path=ppt/notesSlides/notesSlide11.xml><?xml version="1.0" encoding="utf-8"?>
+<p:notes xmlns:a="http://schemas.openxmlformats.org/drawingml/2006/main" xmlns:r="http://schemas.openxmlformats.org/officeDocument/2006/relationships" xmlns:p="http://schemas.openxmlformats.org/presentationml/2006/main">
+  <p:cSld>
+    <p:spTree>
+      <p:nvGrpSpPr>
+        <p:cNvPr id="1" name=""/>
+        <p:cNvGrpSpPr/>
+        <p:nvPr/>
+      </p:nvGrpSpPr>
+      <p:grpSpPr>
+        <a:xfrm>
+          <a:off x="0" y="0"/>
+          <a:ext cx="0" cy="0"/>
+          <a:chOff x="0" y="0"/>
+          <a:chExt cx="0" cy="0"/>
+        </a:xfrm>
+      </p:grpSpPr>
+      <p:sp>
+        <p:nvSpPr>
+          <p:cNvPr id="2" name="Slide Image Placeholder 1"/>
+          <p:cNvSpPr>
+            <a:spLocks noGrp="1" noRot="1" noChangeAspect="1"/>
+          </p:cNvSpPr>
+          <p:nvPr>
+            <p:ph type="sldImg" idx="2"/>
+          </p:nvPr>
+        </p:nvSpPr>
+        <p:spPr/>
+      </p:sp>
+      <p:sp>
+        <p:nvSpPr>
+          <p:cNvPr id="3" name="Notes Placeholder 2"/>
+          <p:cNvSpPr>
+            <a:spLocks noGrp="1"/>
+          </p:cNvSpPr>
+          <p:nvPr>
+            <p:ph type="body" sz="quarter" idx="3"/>
+          </p:nvPr>
+        </p:nvSpPr>
+        <p:spPr/>
+        <p:txBody>
+          <a:bodyPr/>
+          <a:lstStyle/>
+          <a:p>
+            <a:r>
+              <a:rPr lang="en-US" dirty="0"/>
+              <a:t>11_two_layers</a:t>
+            </a:r>
+          </a:p>
+          <a:p>
+            <a:endParaRPr lang="en-US" dirty="0"/>
+          </a:p>
+          <a:p>
+            <a:r>
+              <a:rPr lang="en-US" dirty="0"/>
+              <a:t>[เปิดเรื่อง]</a:t>
+            </a:r>
+          </a:p>
+          <a:p>
+            <a:r>
+              <a:rPr lang="en-US" dirty="0"/>
+              <a:t>เพื่อป้องกันปัญหาที่เราคุยกันเมื่อสักครู่ ระบบตรวจสอบในด่าน Handoff จึงถูกแบ่งออกเป็น 2 ชั้นแยกกันอย่างตั้งใจครับ</a:t>
+            </a:r>
+          </a:p>
+          <a:p>
+            <a:endParaRPr lang="en-US" dirty="0"/>
+          </a:p>
+          <a:p>
+            <a:r>
+              <a:rPr lang="en-US" dirty="0"/>
+              <a:t>[ขยายความ]</a:t>
+            </a:r>
+          </a:p>
+          <a:p>
+            <a:r>
+              <a:rPr lang="en-US" dirty="0"/>
+              <a:t>ชั้นที่ 1 คือ Deterministic Layer (เครื่องตรวจสิ่งที่พิสูจน์ได้): ชั้นนี้คอมพิวเตอร์เป็นคนตรวจครับ เช่น โครงสร้างไฟล์ กฎความสอดคล้อง กฎพวกนี้จะไม่เดาความหมายเชิงธุรกิจเลย เพราะถ้า Validator พยายามจะเดาแล้วเดาผิด คนจะเริ่มเพิกเฉยต่อคำเตือนของมัน</a:t>
+            </a:r>
+          </a:p>
+          <a:p>
+            <a:r>
+              <a:rPr lang="en-US" dirty="0"/>
+              <a:t>ชั้นที่ 2 คือ Semantic Review (คนหรือ AI ช่วยตรวจความสมเหตุสมผล): ชั้นนี้จะใช้อ่านเนื้อหาเชิงลึกครับ เพื่อดูว่าสัญญาทั้งหมดมัน Make sense ไหม โดยมีเกณฑ์การอ่านอยู่ 12 เลนส์ ซึ่งการรีวิวนี้เป็นแค่การเก็บเป็น "หลักฐาน" ไม่ใช่การอนุมัตินะครับ</a:t>
+            </a:r>
+          </a:p>
+          <a:p>
+            <a:endParaRPr lang="en-US" dirty="0"/>
+          </a:p>
+          <a:p>
+            <a:r>
+              <a:rPr lang="en-US" dirty="0"/>
+              <a:t>และที่สำคัญ เรื่องที่เกี่ยวกับ Privacy และ Environment AI จะไม่มีสิทธิ์ปิด Finding หรือปัญหาเหล่านั้นได้ด้วยตัวเอง การตัดสินใจเรื่องพวกนี้เป็นของคน 100% ครับ "คำสั่งที่บอกให้ AI อย่าปิด finding ไม่ใช่การควบคุม แต่กฎที่ทำให้ด่านตรวจ Fail เมื่อ AI พยายามจะปิด นั่นแหละคือการควบคุม"</a:t>
+            </a:r>
+          </a:p>
+          <a:p>
+            <a:endParaRPr lang="en-US" dirty="0"/>
+          </a:p>
+          <a:p>
+            <a:r>
+              <a:rPr lang="en-US" dirty="0"/>
+              <a:t>[คำถามที่อาจพบ &amp; สำหรับสายเทคนิค]</a:t>
+            </a:r>
+          </a:p>
+          <a:p>
+            <a:r>
+              <a:rPr lang="en-US" dirty="0"/>
+              <a:t>อธิบายเพิ่มสำหรับสายเทคนิคนะครับ, กฎ Handoff-001 ถึง 014 จะรันอยู่ใน Layer 1 ทำหน้าที่แค่ Parser และ Link checker ล้วนๆ แต่ถ้าเป็นเชิงความหมายจะถูกโยนไปที่ `HANDOFF-REVIEW.json` เพื่อทำ Semantic review ใน Layer 2 ครับ</a:t>
+            </a:r>
+          </a:p>
+          <a:p>
+            <a:endParaRPr lang="en-US" dirty="0"/>
+          </a:p>
+          <a:p>
+            <a:r>
+              <a:rPr lang="en-US" dirty="0"/>
+              <a:t>[ส่งเข้าหน้าถัดไป]</a:t>
+            </a:r>
+          </a:p>
+          <a:p>
+            <a:r>
+              <a:rPr lang="en-US" dirty="0"/>
+              <a:t>แล้ว 12 เลนส์ที่ใช้รีวิวความสมเหตุสมผลในชั้นที่ 2 มีอะไรบ้าง? เรามาดูกันครับ</a:t>
+            </a:r>
+          </a:p>
+        </p:txBody>
+      </p:sp>
+    </p:spTree>
+  </p:cSld>
+  <p:clrMapOvr>
+    <a:masterClrMapping/>
+  </p:clrMapOvr>
+</p:notes>
+</file>
+
+<file path=ppt/notesSlides/notesSlide12.xml><?xml version="1.0" encoding="utf-8"?>
+<p:notes xmlns:a="http://schemas.openxmlformats.org/drawingml/2006/main" xmlns:r="http://schemas.openxmlformats.org/officeDocument/2006/relationships" xmlns:p="http://schemas.openxmlformats.org/presentationml/2006/main">
+  <p:cSld>
+    <p:spTree>
+      <p:nvGrpSpPr>
+        <p:cNvPr id="1" name=""/>
+        <p:cNvGrpSpPr/>
+        <p:nvPr/>
+      </p:nvGrpSpPr>
+      <p:grpSpPr>
+        <a:xfrm>
+          <a:off x="0" y="0"/>
+          <a:ext cx="0" cy="0"/>
+          <a:chOff x="0" y="0"/>
+          <a:chExt cx="0" cy="0"/>
+        </a:xfrm>
+      </p:grpSpPr>
+      <p:sp>
+        <p:nvSpPr>
+          <p:cNvPr id="2" name="Slide Image Placeholder 1"/>
+          <p:cNvSpPr>
+            <a:spLocks noGrp="1" noRot="1" noChangeAspect="1"/>
+          </p:cNvSpPr>
+          <p:nvPr>
+            <p:ph type="sldImg" idx="2"/>
+          </p:nvPr>
+        </p:nvSpPr>
+        <p:spPr/>
+      </p:sp>
+      <p:sp>
+        <p:nvSpPr>
+          <p:cNvPr id="3" name="Notes Placeholder 2"/>
+          <p:cNvSpPr>
+            <a:spLocks noGrp="1"/>
+          </p:cNvSpPr>
+          <p:nvPr>
+            <p:ph type="body" sz="quarter" idx="3"/>
+          </p:nvPr>
+        </p:nvSpPr>
+        <p:spPr/>
+        <p:txBody>
+          <a:bodyPr/>
+          <a:lstStyle/>
+          <a:p>
+            <a:r>
+              <a:rPr lang="en-US" dirty="0"/>
+              <a:t>12_twelve_lenses</a:t>
+            </a:r>
+          </a:p>
+          <a:p>
+            <a:endParaRPr lang="en-US" dirty="0"/>
+          </a:p>
+          <a:p>
+            <a:r>
+              <a:rPr lang="en-US" dirty="0"/>
+              <a:t>[เปิดเรื่อง]</a:t>
+            </a:r>
+          </a:p>
+          <a:p>
+            <a:r>
+              <a:rPr lang="en-US" dirty="0"/>
+              <a:t>สิบสองเลนส์นี้ ไม่ใช่เวทมนตร์อะไรหรอกครับ แต่มันคือ 12 คำถามพื้นฐานที่บรรดา Tech Lead หรือคนตรวจงานเก่งๆ เขามักจะถามกันอยู่แล้ว เราแค่จับมันมาเขียนลงไฟล์ให้ AI ถามให้ครบทุกครั้งเท่านั้นเอง</a:t>
+            </a:r>
+          </a:p>
+          <a:p>
+            <a:endParaRPr lang="en-US" dirty="0"/>
+          </a:p>
+          <a:p>
+            <a:r>
+              <a:rPr lang="en-US" dirty="0"/>
+              <a:t>[ขยายความ]</a:t>
+            </a:r>
+          </a:p>
+          <a:p>
+            <a:r>
+              <a:rPr lang="en-US" dirty="0"/>
+              <a:t>เพื่อให้เห็นภาพ เลนส์พวกนี้จะถามคำถามอย่างเช่น:</a:t>
+            </a:r>
+          </a:p>
+          <a:p>
+            <a:r>
+              <a:rPr lang="en-US" dirty="0"/>
+              <a:t>• ขอบเขตที่ตัดมา ส่งมอบคุณค่าได้จริงไหม?</a:t>
+            </a:r>
+          </a:p>
+          <a:p>
+            <a:r>
+              <a:rPr lang="en-US" dirty="0"/>
+              <a:t>• รองรับ Use case ครบหรือเปล่า หรือมีแต่ Happy path?</a:t>
+            </a:r>
+          </a:p>
+          <a:p>
+            <a:r>
+              <a:rPr lang="en-US" dirty="0"/>
+              <a:t>• มีการจัดการเรื่อง State Transitions และ Rollback เตรียมไว้ไหมเวลาพัง?</a:t>
+            </a:r>
+          </a:p>
+          <a:p>
+            <a:r>
+              <a:rPr lang="en-US" dirty="0"/>
+              <a:t>• มีเจ้าของงานชัดเจนหรือเปล่า?</a:t>
+            </a:r>
+          </a:p>
+          <a:p>
+            <a:endParaRPr lang="en-US" dirty="0"/>
+          </a:p>
+          <a:p>
+            <a:r>
+              <a:rPr lang="en-US" dirty="0"/>
+              <a:t>ทุกเลนส์จะต้องถูกพิจารณา และหา Finding ถ้ามีปัญหา แต่จุดที่ผมอยากให้สังเกตคือจุดสีแดงตรงมุมขวาบนในข้อ 10 และ 11 ครับ</a:t>
+            </a:r>
+          </a:p>
+          <a:p>
+            <a:r>
+              <a:rPr lang="en-US" dirty="0"/>
+              <a:t>เรื่อง "Privacy และการจัดชั้นข้อมูล" กับ "ข้อจำกัดด้าน Environment" สองเลนส์นี้เป็นขอบเขตอำนาจของ "มนุษย์เท่านั้น (Human-only)" AI ไม่สามารถตัดสินใจแทนเราได้ครับ</a:t>
+            </a:r>
+          </a:p>
+          <a:p>
+            <a:endParaRPr lang="en-US" dirty="0"/>
+          </a:p>
+          <a:p>
+            <a:r>
+              <a:rPr lang="en-US" dirty="0"/>
+              <a:t>[คำถามที่อาจพบ &amp; สำหรับสายเทคนิค]</a:t>
+            </a:r>
+          </a:p>
+          <a:p>
+            <a:r>
+              <a:rPr lang="en-US" dirty="0"/>
+              <a:t>อีกเรื่องที่สำคัญคือ Finding ทุกอันจะต้องมี "หลักฐาน" อ้างอิงด้วยนะครับ หาไม่มีหลักฐานมาอ้าง มันเป็นแค่ความเห็น ไม่ใช่ Finding ครับ</a:t>
+            </a:r>
+          </a:p>
+          <a:p>
+            <a:endParaRPr lang="en-US" dirty="0"/>
+          </a:p>
+          <a:p>
+            <a:r>
+              <a:rPr lang="en-US" dirty="0"/>
+              <a:t>[ส่งเข้าหน้าถัดไป]</a:t>
+            </a:r>
+          </a:p>
+          <a:p>
+            <a:r>
+              <a:rPr lang="en-US" dirty="0"/>
+              <a:t>พอเราเอา 12 เลนส์นี้ไปตรวจแล้ว ผลที่ออกมามันจะบอกว่าผ่านหรือไม่ผ่านง่ายๆ เลยหรือเปล่า? คำตอบคือไม่ใช่อย่างนั้นครับ</a:t>
+            </a:r>
+          </a:p>
+        </p:txBody>
+      </p:sp>
+    </p:spTree>
+  </p:cSld>
+  <p:clrMapOvr>
+    <a:masterClrMapping/>
+  </p:clrMapOvr>
+</p:notes>
+</file>
+
+<file path=ppt/notesSlides/notesSlide13.xml><?xml version="1.0" encoding="utf-8"?>
+<p:notes xmlns:a="http://schemas.openxmlformats.org/drawingml/2006/main" xmlns:r="http://schemas.openxmlformats.org/officeDocument/2006/relationships" xmlns:p="http://schemas.openxmlformats.org/presentationml/2006/main">
+  <p:cSld>
+    <p:spTree>
+      <p:nvGrpSpPr>
+        <p:cNvPr id="1" name=""/>
+        <p:cNvGrpSpPr/>
+        <p:nvPr/>
+      </p:nvGrpSpPr>
+      <p:grpSpPr>
+        <a:xfrm>
+          <a:off x="0" y="0"/>
+          <a:ext cx="0" cy="0"/>
+          <a:chOff x="0" y="0"/>
+          <a:chExt cx="0" cy="0"/>
+        </a:xfrm>
+      </p:grpSpPr>
+      <p:sp>
+        <p:nvSpPr>
+          <p:cNvPr id="2" name="Slide Image Placeholder 1"/>
+          <p:cNvSpPr>
+            <a:spLocks noGrp="1" noRot="1" noChangeAspect="1"/>
+          </p:cNvSpPr>
+          <p:nvPr>
+            <p:ph type="sldImg" idx="2"/>
+          </p:nvPr>
+        </p:nvSpPr>
+        <p:spPr/>
+      </p:sp>
+      <p:sp>
+        <p:nvSpPr>
+          <p:cNvPr id="3" name="Notes Placeholder 2"/>
+          <p:cNvSpPr>
+            <a:spLocks noGrp="1"/>
+          </p:cNvSpPr>
+          <p:nvPr>
+            <p:ph type="body" sz="quarter" idx="3"/>
+          </p:nvPr>
+        </p:nvSpPr>
+        <p:spPr/>
+        <p:txBody>
+          <a:bodyPr/>
+          <a:lstStyle/>
+          <a:p>
+            <a:r>
+              <a:rPr lang="en-US" dirty="0"/>
+              <a:t>13_readiness_and_score</a:t>
+            </a:r>
+          </a:p>
+          <a:p>
+            <a:endParaRPr lang="en-US" dirty="0"/>
+          </a:p>
+          <a:p>
+            <a:r>
+              <a:rPr lang="en-US" dirty="0"/>
+              <a:t>[เปิดเรื่อง]</a:t>
+            </a:r>
+          </a:p>
+          <a:p>
+            <a:r>
+              <a:rPr lang="en-US" dirty="0"/>
+              <a:t>เวลาจะส่งงานต่อ เรามักจะอยากได้คำตอบง่ายๆ ว่า "พร้อม" หรือ "ไม่พร้อม" แต่ในโลกความเป็นจริง ความพร้อมไม่ใช่ค่าเดียวครับ</a:t>
+            </a:r>
+          </a:p>
+          <a:p>
+            <a:endParaRPr lang="en-US" dirty="0"/>
+          </a:p>
+          <a:p>
+            <a:r>
+              <a:rPr lang="en-US" dirty="0"/>
+              <a:t>[ขยายความ]</a:t>
+            </a:r>
+          </a:p>
+          <a:p>
+            <a:r>
+              <a:rPr lang="en-US" dirty="0"/>
+              <a:t>[สำหรับผู้บริหาร]: การยุบทุกอย่างให้เหลือแค่ "พร้อม" หรือ "ไม่พร้อม" มันทำให้เราต้องเลือกระหว่าง การเบรกทีมงานที่จริงๆ แล้วเริ่มเขียนโค้ดได้ กับการยอมปล่อยผ่านโปรเจกต์ที่ยังเอาไปเดโมให้ลูกค้าดูไม่ได้ เราเลยประเมินความพร้อมออกมาเป็น 6 มิติ (ฝั่งซ้าย) ควบคู่กับคะแนน 7 ด้าน (ฝั่งขวา) ครับ</a:t>
+            </a:r>
+          </a:p>
+          <a:p>
+            <a:r>
+              <a:rPr lang="en-US" dirty="0"/>
+              <a:t>[สำหรับทีมเทคนิค]: ตรง 6 มิตินี้ สถานะมันไม่ได้มีแค่ True/False นะครับ แต่มันมีสถานะ `null` ด้วย `null` แปลว่า "ยังไม่ได้รีวิว" ซึ่งสำคัญมาก เพราะการที่เราบอกว่าไม่มี Finding ที่บันทึกไว้ มันต่างจากการที่มีหลักฐานยืนยันว่าไม่มีปัญหานะครับ</a:t>
+            </a:r>
+          </a:p>
+          <a:p>
+            <a:endParaRPr lang="en-US" dirty="0"/>
+          </a:p>
+          <a:p>
+            <a:r>
+              <a:rPr lang="en-US" dirty="0"/>
+              <a:t>นอกจากนี้ คะแนนที่เห็นฝั่งขวา จะมีเพดาน (Cap) บังคับไว้ด้วย เช่น ถ้าเกิด Fail ในจุดสำคัญ คะแนนจะโดนตัดหักทันที ไม่ให้เกินค่าสูงสุดที่กำหนดไว้ เพื่อบอกให้รู้ว่า "คะแนนสูง ไม่ได้แปลว่าอนุมัติให้ผ่าน"</a:t>
+            </a:r>
+          </a:p>
+          <a:p>
+            <a:endParaRPr lang="en-US" dirty="0"/>
+          </a:p>
+          <a:p>
+            <a:r>
+              <a:rPr lang="en-US" dirty="0"/>
+              <a:t>[คำถามที่อาจพบ &amp; สำหรับสายเทคนิค]</a:t>
+            </a:r>
+          </a:p>
+          <a:p>
+            <a:r>
+              <a:rPr lang="en-US" dirty="0"/>
+              <a:t>ระบบคำนวณคะแนนนี้ดึงค่ามาจาก `pmo-config/handoff-policy.json` ตรงๆ เลยครับ ถ้ามี Critical finding ที่ Block ก่อนเข้าโหมด Build ต่อให้ด้านอื่นดีหมด คะแนนก็จะโดนกดให้ไม่เกิน 49 ทันที</a:t>
+            </a:r>
+          </a:p>
+          <a:p>
+            <a:endParaRPr lang="en-US" dirty="0"/>
+          </a:p>
+          <a:p>
+            <a:r>
+              <a:rPr lang="en-US" dirty="0"/>
+              <a:t>[ส่งเข้าหน้าถัดไป]</a:t>
+            </a:r>
+          </a:p>
+          <a:p>
+            <a:r>
+              <a:rPr lang="en-US" dirty="0"/>
+              <a:t>เพื่อให้เห็นภาพชัดเจนที่สุด ผมมีตัวอย่างโปรเจกต์ 2 ตัวที่ดูเหมือนจะพร้อมเท่ากัน แต่ผลลัพธ์ต่างกันลิบลับ มาดูกันครับ</a:t>
+            </a:r>
+          </a:p>
+        </p:txBody>
+      </p:sp>
+    </p:spTree>
+  </p:cSld>
+  <p:clrMapOvr>
+    <a:masterClrMapping/>
+  </p:clrMapOvr>
+</p:notes>
+</file>
+
+<file path=ppt/notesSlides/notesSlide14.xml><?xml version="1.0" encoding="utf-8"?>
+<p:notes xmlns:a="http://schemas.openxmlformats.org/drawingml/2006/main" xmlns:r="http://schemas.openxmlformats.org/officeDocument/2006/relationships" xmlns:p="http://schemas.openxmlformats.org/presentationml/2006/main">
+  <p:cSld>
+    <p:spTree>
+      <p:nvGrpSpPr>
+        <p:cNvPr id="1" name=""/>
+        <p:cNvGrpSpPr/>
+        <p:nvPr/>
+      </p:nvGrpSpPr>
+      <p:grpSpPr>
+        <a:xfrm>
+          <a:off x="0" y="0"/>
+          <a:ext cx="0" cy="0"/>
+          <a:chOff x="0" y="0"/>
+          <a:chExt cx="0" cy="0"/>
+        </a:xfrm>
+      </p:grpSpPr>
+      <p:sp>
+        <p:nvSpPr>
+          <p:cNvPr id="2" name="Slide Image Placeholder 1"/>
+          <p:cNvSpPr>
+            <a:spLocks noGrp="1" noRot="1" noChangeAspect="1"/>
+          </p:cNvSpPr>
+          <p:nvPr>
+            <p:ph type="sldImg" idx="2"/>
+          </p:nvPr>
+        </p:nvSpPr>
+        <p:spPr/>
+      </p:sp>
+      <p:sp>
+        <p:nvSpPr>
+          <p:cNvPr id="3" name="Notes Placeholder 2"/>
+          <p:cNvSpPr>
+            <a:spLocks noGrp="1"/>
+          </p:cNvSpPr>
+          <p:nvPr>
+            <p:ph type="body" sz="quarter" idx="3"/>
+          </p:nvPr>
+        </p:nvSpPr>
+        <p:spPr/>
+        <p:txBody>
+          <a:bodyPr/>
+          <a:lstStyle/>
+          <a:p>
+            <a:r>
+              <a:rPr lang="en-US" dirty="0"/>
+              <a:t>14_broken_vs_fixed</a:t>
+            </a:r>
+          </a:p>
+          <a:p>
+            <a:endParaRPr lang="en-US" dirty="0"/>
+          </a:p>
+          <a:p>
+            <a:r>
+              <a:rPr lang="en-US" dirty="0"/>
+              <a:t>[เปิดเรื่อง]</a:t>
+            </a:r>
+          </a:p>
+          <a:p>
+            <a:r>
+              <a:rPr lang="en-US" dirty="0"/>
+              <a:t>หน้าต่างนี้คือบทพิสูจน์ที่ชัดเจนที่สุดครับว่า ทำไมการตรวจเอกสารแค่ว่า "กรอกครบไหม" ถึงไม่พอ</a:t>
+            </a:r>
+          </a:p>
+          <a:p>
+            <a:endParaRPr lang="en-US" dirty="0"/>
+          </a:p>
+          <a:p>
+            <a:r>
+              <a:rPr lang="en-US" dirty="0"/>
+              <a:t>[ขยายความ]</a:t>
+            </a:r>
+          </a:p>
+          <a:p>
+            <a:r>
+              <a:rPr lang="en-US" dirty="0"/>
+              <a:t>[สำหรับผู้บริหาร]: สมมติเรามีโปรเจกต์ 2 ตัวที่กรอกฟอร์มครบทุกช่องเหมือนกัน ถ้าตรวจแบบเดิม ทั้งคู่ผ่านครับ แต่พอเราใช้ Axiom-PMO เข้ามาจับ มันจะเจอปัญหาที่ซ่อนอยู่ เช่น เรื่องลำดับการ Build ผิด หรือเคสเดโมไปเปิดเว็บกล้องในเครื่องที่ไม่มี HTTPS ปัญหาพวกนี้จะทำให้งานสะดุดและเสียเวลาเป็นวันๆ ทันที</a:t>
+            </a:r>
+          </a:p>
+          <a:p>
+            <a:r>
+              <a:rPr lang="en-US" dirty="0"/>
+              <a:t>[สำหรับทีมเทคนิค]: ลองดูตารางเปรียบเทียบครับ กฎอย่าง `HANDOFF-004` จะเห็นว่าลำดับของ Schema กลางไปอยู่หลังสุด ซึ่งมันผิดหลัก Dependency พอรันด้วยระบบของเรา มันจะฟ้องทันทีว่า "Ready to build, but NOT ready to demo"</a:t>
+            </a:r>
+          </a:p>
+          <a:p>
+            <a:endParaRPr lang="en-US" dirty="0"/>
+          </a:p>
+          <a:p>
+            <a:r>
+              <a:rPr lang="en-US" dirty="0"/>
+              <a:t>สังเกตนะครับว่าคะแนนมันคือ 92 ไม่ใช่ 100 เต็ม เพราะโปรเจกต์ที่ตัวเอกสารมันเองยังฟ้องว่าเอาไปเดโมไม่ได้ เราก็ไม่ควรอ่านค่าความสำเร็จของมันว่าสมบูรณ์แบบครับ</a:t>
+            </a:r>
+          </a:p>
+          <a:p>
+            <a:endParaRPr lang="en-US" dirty="0"/>
+          </a:p>
+          <a:p>
+            <a:r>
+              <a:rPr lang="en-US" dirty="0"/>
+              <a:t>[คำถามที่อาจพบ &amp; สำหรับสายเทคนิค]</a:t>
+            </a:r>
+          </a:p>
+          <a:p>
+            <a:r>
+              <a:rPr lang="en-US" dirty="0"/>
+              <a:t>จุดที่น่าสนใจคือ Semantic review มันจะฟ้องอุปกรณ์เดโม (ที่ยังไม่พร้อม) ส่วน `HANDOFF.md` ฟ้องเรื่อง Certificate ทั้งสองปัญหาหยุดการเดโม แต่ไม่ได้หยุด Dev ไม่ให้เขียนโค้ด ดังนั้น Gate นี้ก็จะไม่ Block การเริ่มทำงานแบบเหมารวมครับ</a:t>
+            </a:r>
+          </a:p>
+          <a:p>
+            <a:endParaRPr lang="en-US" dirty="0"/>
+          </a:p>
+          <a:p>
+            <a:r>
+              <a:rPr lang="en-US" dirty="0"/>
+              <a:t>[ส่งเข้าหน้าถัดไป]</a:t>
+            </a:r>
+          </a:p>
+          <a:p>
+            <a:r>
+              <a:rPr lang="en-US" dirty="0"/>
+              <a:t>ทั้งหมดที่เราพูดมานี้ ไม่ใช่แค่ทฤษฎีในกระดาษนะครับ มันมีตัวตนอยู่จริงและรันได้จริงๆ ในหน้าสุดท้ายนี้ ผมจะโชว์ให้ดูครับ</a:t>
+            </a:r>
+          </a:p>
+        </p:txBody>
+      </p:sp>
+    </p:spTree>
+  </p:cSld>
+  <p:clrMapOvr>
+    <a:masterClrMapping/>
+  </p:clrMapOvr>
+</p:notes>
+</file>
+
+<file path=ppt/notesSlides/notesSlide15.xml><?xml version="1.0" encoding="utf-8"?>
+<p:notes xmlns:a="http://schemas.openxmlformats.org/drawingml/2006/main" xmlns:r="http://schemas.openxmlformats.org/officeDocument/2006/relationships" xmlns:p="http://schemas.openxmlformats.org/presentationml/2006/main">
+  <p:cSld>
+    <p:spTree>
+      <p:nvGrpSpPr>
+        <p:cNvPr id="1" name=""/>
+        <p:cNvGrpSpPr/>
+        <p:nvPr/>
+      </p:nvGrpSpPr>
+      <p:grpSpPr>
+        <a:xfrm>
+          <a:off x="0" y="0"/>
+          <a:ext cx="0" cy="0"/>
+          <a:chOff x="0" y="0"/>
+          <a:chExt cx="0" cy="0"/>
+        </a:xfrm>
+      </p:grpSpPr>
+      <p:sp>
+        <p:nvSpPr>
+          <p:cNvPr id="2" name="Slide Image Placeholder 1"/>
+          <p:cNvSpPr>
+            <a:spLocks noGrp="1" noRot="1" noChangeAspect="1"/>
+          </p:cNvSpPr>
+          <p:nvPr>
+            <p:ph type="sldImg" idx="2"/>
+          </p:nvPr>
+        </p:nvSpPr>
+        <p:spPr/>
+      </p:sp>
+      <p:sp>
+        <p:nvSpPr>
+          <p:cNvPr id="3" name="Notes Placeholder 2"/>
+          <p:cNvSpPr>
+            <a:spLocks noGrp="1"/>
+          </p:cNvSpPr>
+          <p:nvPr>
+            <p:ph type="body" sz="quarter" idx="3"/>
+          </p:nvPr>
+        </p:nvSpPr>
+        <p:spPr/>
+        <p:txBody>
+          <a:bodyPr/>
+          <a:lstStyle/>
+          <a:p>
+            <a:r>
+              <a:rPr lang="en-US" dirty="0"/>
+              <a:t>15_unenforceable_rules</a:t>
+            </a:r>
+          </a:p>
+          <a:p>
+            <a:endParaRPr lang="en-US" dirty="0"/>
+          </a:p>
+          <a:p>
+            <a:r>
+              <a:rPr lang="en-US" dirty="0"/>
+              <a:t>[เปิดเรื่อง]</a:t>
+            </a:r>
+          </a:p>
+          <a:p>
+            <a:r>
+              <a:rPr lang="en-US" dirty="0"/>
+              <a:t>เราพูดถึงทฤษฎีกันมาเยอะแล้ว อยากให้ทุกท่านจำประโยคนี้กลับไปครับ: "กฎที่บังคับไม่ได้ ไม่ใช่กฎ"</a:t>
+            </a:r>
+          </a:p>
+          <a:p>
+            <a:endParaRPr lang="en-US" dirty="0"/>
+          </a:p>
+          <a:p>
+            <a:r>
+              <a:rPr lang="en-US" dirty="0"/>
+              <a:t>[ขยายความ]</a:t>
+            </a:r>
+          </a:p>
+          <a:p>
+            <a:r>
+              <a:rPr lang="en-US" dirty="0"/>
+              <a:t>สิ่งที่อยู่ใน Axiom-PMO ไม่ใช่แค่ข้อความในไฟล์ PDF หรือ Confluence ครับ แต่มันคือ "โค้ด" ที่รันได้จริง ทดสอบแล้ว และมันพร้อมจะ "ล้มเหลว" เมื่อเจอความผิดปกติ</a:t>
+            </a:r>
+          </a:p>
+          <a:p>
+            <a:r>
+              <a:rPr lang="en-US" dirty="0"/>
+              <a:t>เรามี Validation Rules 82 กฎ, เลนส์สำหรับ Review 12 เลนส์, เคสทดสอบ 148 เคส และโค้ด PowerShell กว่า 5,400 บรรทัดที่ทำงานอยู่เบื้องหลัง</a:t>
+            </a:r>
+          </a:p>
+          <a:p>
+            <a:endParaRPr lang="en-US" dirty="0"/>
+          </a:p>
+          <a:p>
+            <a:r>
+              <a:rPr lang="en-US" dirty="0"/>
+              <a:t>ระบบมีกลไกป้องกันตัวเองอย่างเหนียวแน่น (ซ้ายมือ) เช่น การทำ Config-mutation test เพื่อให้แน่ใจว่าถ้าแก้ Policy แล้ว พฤติกรรมของกฎต้องเปลี่ยนตาม ถ้า AI ดันสร้างเอกสารหลอกๆ หรืออ้างอิงหน้าเอกสารที่ไม่มีอยู่จริง ตัว Validator ก็จะเตะให้ Fail ทันที</a:t>
+            </a:r>
+          </a:p>
+          <a:p>
+            <a:r>
+              <a:rPr lang="en-US" dirty="0"/>
+              <a:t>ฝั่งขวามือคือคำสั่งที่คุณสามารถพิมพ์แล้วรันได้เลยตอนนี้</a:t>
+            </a:r>
+          </a:p>
+          <a:p>
+            <a:endParaRPr lang="en-US" dirty="0"/>
+          </a:p>
+          <a:p>
+            <a:r>
+              <a:rPr lang="en-US" dirty="0"/>
+              <a:t>[คำถามที่อาจพบ &amp; สำหรับสายเทคนิค]</a:t>
+            </a:r>
+          </a:p>
+          <a:p>
+            <a:r>
+              <a:rPr lang="en-US" dirty="0"/>
+              <a:t>สำหรับทีมเทคนิคที่อยากเริ่มรัน แค่เรียก `validate-project.ps1` หรือ `assess-handoff.ps1` คุณก็จะได้ Exit Code ออกมา 0, 1, 2 ตามมาตรฐาน CI เลยครับ ระบบพัฒนาบน PowerShell 5.1 เพื่อให้มั่นคงที่สุดใน Windows CI</a:t>
+            </a:r>
+          </a:p>
+          <a:p>
+            <a:endParaRPr lang="en-US" dirty="0"/>
+          </a:p>
+          <a:p>
+            <a:r>
+              <a:rPr lang="en-US" dirty="0"/>
+              <a:t>[ปิดท้าย]</a:t>
+            </a:r>
+          </a:p>
+          <a:p>
+            <a:r>
+              <a:rPr lang="en-US" dirty="0"/>
+              <a:t>ท้ายที่สุดนี้ AI อาจจะเก่งเรื่องการ Build หรือเขียนโค้ดครับ แต่ Axiom-PMO คือคนที่จะคอยตรวจสอบความถูกต้อง ทั้งขอบเขต หลักฐาน และอำนาจเบื้องหลังงานชิ้นนั้น เพื่อให้เรานำ AI มาใช้งานได้อย่างมั่นใจ ขอบคุณครับ</a:t>
+            </a:r>
+          </a:p>
+        </p:txBody>
+      </p:sp>
+    </p:spTree>
+  </p:cSld>
+  <p:clrMapOvr>
+    <a:masterClrMapping/>
+  </p:clrMapOvr>
+</p:notes>
+</file>
+
+<file path=ppt/notesSlides/notesSlide2.xml><?xml version="1.0" encoding="utf-8"?>
+<p:notes xmlns:a="http://schemas.openxmlformats.org/drawingml/2006/main" xmlns:r="http://schemas.openxmlformats.org/officeDocument/2006/relationships" xmlns:p="http://schemas.openxmlformats.org/presentationml/2006/main">
+  <p:cSld>
+    <p:spTree>
+      <p:nvGrpSpPr>
+        <p:cNvPr id="1" name=""/>
+        <p:cNvGrpSpPr/>
+        <p:nvPr/>
+      </p:nvGrpSpPr>
+      <p:grpSpPr>
+        <a:xfrm>
+          <a:off x="0" y="0"/>
+          <a:ext cx="0" cy="0"/>
+          <a:chOff x="0" y="0"/>
+          <a:chExt cx="0" cy="0"/>
+        </a:xfrm>
+      </p:grpSpPr>
+      <p:sp>
+        <p:nvSpPr>
+          <p:cNvPr id="2" name="Slide Image Placeholder 1"/>
+          <p:cNvSpPr>
+            <a:spLocks noGrp="1" noRot="1" noChangeAspect="1"/>
+          </p:cNvSpPr>
+          <p:nvPr>
+            <p:ph type="sldImg" idx="2"/>
+          </p:nvPr>
+        </p:nvSpPr>
+        <p:spPr/>
+      </p:sp>
+      <p:sp>
+        <p:nvSpPr>
+          <p:cNvPr id="3" name="Notes Placeholder 2"/>
+          <p:cNvSpPr>
+            <a:spLocks noGrp="1"/>
+          </p:cNvSpPr>
+          <p:nvPr>
+            <p:ph type="body" sz="quarter" idx="3"/>
+          </p:nvPr>
+        </p:nvSpPr>
+        <p:spPr/>
+        <p:txBody>
+          <a:bodyPr/>
+          <a:lstStyle/>
+          <a:p>
+            <a:r>
+              <a:rPr lang="en-US" dirty="0"/>
+              <a:t>02_the_question</a:t>
+            </a:r>
+          </a:p>
+          <a:p>
+            <a:endParaRPr lang="en-US" dirty="0"/>
+          </a:p>
+          <a:p>
+            <a:r>
+              <a:rPr lang="en-US" dirty="0"/>
+              <a:t>[เปิดเรื่อง]</a:t>
+            </a:r>
+          </a:p>
+          <a:p>
+            <a:r>
+              <a:rPr lang="en-US" dirty="0"/>
+              <a:t>ปัญหาที่แท้จริงของการให้ AI ทำงานให้ ไม่ใช่เรื่องที่ว่ามันเขียนโค้ดไม่เป็น หรือทำตามคำสั่งไม่ได้หรอกนะครับ</a:t>
+            </a:r>
+          </a:p>
+          <a:p>
+            <a:endParaRPr lang="en-US" dirty="0"/>
+          </a:p>
+          <a:p>
+            <a:r>
+              <a:rPr lang="en-US" dirty="0"/>
+              <a:t>[ขยายความ]</a:t>
+            </a:r>
+          </a:p>
+          <a:p>
+            <a:r>
+              <a:rPr lang="en-US" dirty="0"/>
+              <a:t>ปัญหาที่น่ากลัวกว่าคือ "ความน่าเชื่อถือ" ครับ สมมติว่า AI ส่งงานที่เสร็จแล้วมาให้เราดูโค้ด คุณจะรู้ได้ยังไงครับว่าสิ่งที่มันทำมาให้เนี่ย คือสิ่งที่ลูกค้าขอมาจริงๆ?</a:t>
+            </a:r>
+          </a:p>
+          <a:p>
+            <a:r>
+              <a:rPr lang="en-US" dirty="0"/>
+              <a:t>ลองถามตัวเองด้วย 3 คำถามนี้ดูครับ:</a:t>
+            </a:r>
+          </a:p>
+          <a:p>
+            <a:r>
+              <a:rPr lang="en-US" dirty="0"/>
+              <a:t>1. Requirement หรือฟีเจอร์ข้อนี้ มีที่มาจากไหน? (AI คิดเอง หรือลูกค้าบอก?)</a:t>
+            </a:r>
+          </a:p>
+          <a:p>
+            <a:r>
+              <a:rPr lang="en-US" dirty="0"/>
+              <a:t>2. ใครเป็นคนอนุมัติ Scope การทำงานนี้?</a:t>
+            </a:r>
+          </a:p>
+          <a:p>
+            <a:r>
+              <a:rPr lang="en-US" dirty="0"/>
+              <a:t>3. ที่บอกว่าเทสต์ผ่าน ใครหรืออะไรเป็นคนยืนยันว่ามันผ่านจริงๆ?</a:t>
+            </a:r>
+          </a:p>
+          <a:p>
+            <a:endParaRPr lang="en-US" dirty="0"/>
+          </a:p>
+          <a:p>
+            <a:r>
+              <a:rPr lang="en-US" dirty="0"/>
+              <a:t>ถ้าเราตอบสามข้อนี้ไม่ได้เลย หรือตอบได้แค่ว่า "ก็ AI มันบอกว่าผ่าน" นั่นแปลว่าโปรเจกต์ของเรายังไม่มี "Governance" หรือการกำกับดูแลที่เหมาะสมเลยครับ</a:t>
+            </a:r>
+          </a:p>
+          <a:p>
+            <a:endParaRPr lang="en-US" dirty="0"/>
+          </a:p>
+          <a:p>
+            <a:r>
+              <a:rPr lang="en-US" dirty="0"/>
+              <a:t>[คำถามที่อาจพบ &amp; สำหรับสายเทคนิค]</a:t>
+            </a:r>
+          </a:p>
+          <a:p>
+            <a:r>
+              <a:rPr lang="en-US" dirty="0"/>
+              <a:t>ทีมเทคนิคอาจจะบอกว่า "ก็ไปดูใน Git log หรือ PR สิ" ใช่ครับ โค้ดน่ะเราดูได้ แต่เราไม่สามารถหา "เจตนา" (Intent) หรือ "แหล่งที่มา" ของการตัดสินใจนั้นในโค้ดได้เลย ถ้าไม่มีบันทึกว่า requirement นี้ผูกกับ ticket ไหน หรือใครเป็นคนไฟเขียว AI อาจจะแอบเพิ่มฟีเจอร์ที่ไม่มีใครขอมาให้เราเนียนๆ ก็ได้</a:t>
+            </a:r>
+          </a:p>
+          <a:p>
+            <a:endParaRPr lang="en-US" dirty="0"/>
+          </a:p>
+          <a:p>
+            <a:r>
+              <a:rPr lang="en-US" dirty="0"/>
+              <a:t>[ส่งเข้าหน้าถัดไป]</a:t>
+            </a:r>
+          </a:p>
+          <a:p>
+            <a:r>
+              <a:rPr lang="en-US" dirty="0"/>
+              <a:t>แล้วถ้าเราปล่อยให้ AI ทำงานไปโดยไม่มี Governance คุมไว้เลยล่ะ มันจะเกิดอะไรขึ้นบ้าง? เราไปดูพฤติกรรมธรรมชาติของ AI เวลาที่ไม่มีคนคุมกันครับ</a:t>
+            </a:r>
+          </a:p>
+        </p:txBody>
+      </p:sp>
+    </p:spTree>
+  </p:cSld>
+  <p:clrMapOvr>
+    <a:masterClrMapping/>
+  </p:clrMapOvr>
+</p:notes>
+</file>
+
+<file path=ppt/notesSlides/notesSlide3.xml><?xml version="1.0" encoding="utf-8"?>
+<p:notes xmlns:a="http://schemas.openxmlformats.org/drawingml/2006/main" xmlns:r="http://schemas.openxmlformats.org/officeDocument/2006/relationships" xmlns:p="http://schemas.openxmlformats.org/presentationml/2006/main">
+  <p:cSld>
+    <p:spTree>
+      <p:nvGrpSpPr>
+        <p:cNvPr id="1" name=""/>
+        <p:cNvGrpSpPr/>
+        <p:nvPr/>
+      </p:nvGrpSpPr>
+      <p:grpSpPr>
+        <a:xfrm>
+          <a:off x="0" y="0"/>
+          <a:ext cx="0" cy="0"/>
+          <a:chOff x="0" y="0"/>
+          <a:chExt cx="0" cy="0"/>
+        </a:xfrm>
+      </p:grpSpPr>
+      <p:sp>
+        <p:nvSpPr>
+          <p:cNvPr id="2" name="Slide Image Placeholder 1"/>
+          <p:cNvSpPr>
+            <a:spLocks noGrp="1" noRot="1" noChangeAspect="1"/>
+          </p:cNvSpPr>
+          <p:nvPr>
+            <p:ph type="sldImg" idx="2"/>
+          </p:nvPr>
+        </p:nvSpPr>
+        <p:spPr/>
+      </p:sp>
+      <p:sp>
+        <p:nvSpPr>
+          <p:cNvPr id="3" name="Notes Placeholder 2"/>
+          <p:cNvSpPr>
+            <a:spLocks noGrp="1"/>
+          </p:cNvSpPr>
+          <p:nvPr>
+            <p:ph type="body" sz="quarter" idx="3"/>
+          </p:nvPr>
+        </p:nvSpPr>
+        <p:spPr/>
+        <p:txBody>
+          <a:bodyPr/>
+          <a:lstStyle/>
+          <a:p>
+            <a:r>
+              <a:rPr lang="en-US" dirty="0"/>
+              <a:t>03_five_behaviours</a:t>
+            </a:r>
+          </a:p>
+          <a:p>
+            <a:endParaRPr lang="en-US" dirty="0"/>
+          </a:p>
+          <a:p>
+            <a:r>
+              <a:rPr lang="en-US" dirty="0"/>
+              <a:t>[เปิดเรื่อง]</a:t>
+            </a:r>
+          </a:p>
+          <a:p>
+            <a:r>
+              <a:rPr lang="en-US" dirty="0"/>
+              <a:t>ถ้าเราปล่อย AI ให้ทำงานไปโดยไม่มี Governance คุม มันไม่ได้แปลว่ามันจะอู้งานนะครับ แต่มันจะทำ 5 พฤติกรรมนี้เสมอ</a:t>
+            </a:r>
+          </a:p>
+          <a:p>
+            <a:endParaRPr lang="en-US" dirty="0"/>
+          </a:p>
+          <a:p>
+            <a:r>
+              <a:rPr lang="en-US" dirty="0"/>
+              <a:t>[ขยายความ]</a:t>
+            </a:r>
+          </a:p>
+          <a:p>
+            <a:r>
+              <a:rPr lang="en-US" dirty="0"/>
+              <a:t>พฤติกรรมพวกนี้ไม่ใช่ "บั๊ก" ของระบบ แต่มันเป็นธรรมชาติของ AI ที่พยายามจะเติมเต็มช่องว่างเวลาที่เราไม่ได้บอกมันให้ชัดเจน:</a:t>
+            </a:r>
+          </a:p>
+          <a:p>
+            <a:r>
+              <a:rPr lang="en-US" dirty="0"/>
+              <a:t>1. Invent: มันจะ "กุ" Requirement หรือคิดเกณฑ์การตรวจรับงาน (Acceptance Criteria) ขึ้นมาเอง โดยที่ไม่มีใครเคยขอ</a:t>
+            </a:r>
+          </a:p>
+          <a:p>
+            <a:r>
+              <a:rPr lang="en-US" dirty="0"/>
+              <a:t>2. Silently expand scope: มันอาจจะแอบเติมฟีเจอร์ที่มันคิดว่า "น่าจะดี" เข้าไปเงียบๆ</a:t>
+            </a:r>
+          </a:p>
+          <a:p>
+            <a:r>
+              <a:rPr lang="en-US" dirty="0"/>
+              <a:t>3. Claim evidence: มันจะอ้างว่าเทสต์ผ่านแล้ว หรือ QA อนุมัติแล้ว ทั้งๆ ที่ตัวมันเองนั่นแหละเป็นคนสร้างหลักฐานนั้นขึ้นมา</a:t>
+            </a:r>
+          </a:p>
+          <a:p>
+            <a:r>
+              <a:rPr lang="en-US" dirty="0"/>
+              <a:t>4. Lose traceability: ทำไปทำมา เราสาวไม่ได้แล้วว่าโค้ดส่วนนี้มาจากคำขอข้อไหน</a:t>
+            </a:r>
+          </a:p>
+          <a:p>
+            <a:r>
+              <a:rPr lang="en-US" dirty="0"/>
+              <a:t>5. Cross authority boundaries: มันอาจจะ commit, push หรือแม้แต่ release งาน โดยที่ไม่รอให้คนที่เป็นเจ้าของระบบอนุมัติ</a:t>
+            </a:r>
+          </a:p>
+          <a:p>
+            <a:endParaRPr lang="en-US" dirty="0"/>
+          </a:p>
+          <a:p>
+            <a:r>
+              <a:rPr lang="en-US" dirty="0"/>
+              <a:t>ทั้งหมดนี้ AI ไม่ได้ตั้งใจจะโกหกเรานะครับ มันแค่ต้องการปิดงานให้เสร็จตามธรรมชาติของมัน</a:t>
+            </a:r>
+          </a:p>
+          <a:p>
+            <a:endParaRPr lang="en-US" dirty="0"/>
+          </a:p>
+          <a:p>
+            <a:r>
+              <a:rPr lang="en-US" dirty="0"/>
+              <a:t>[คำถามที่อาจพบ &amp; สำหรับสายเทคนิค]</a:t>
+            </a:r>
+          </a:p>
+          <a:p>
+            <a:r>
+              <a:rPr lang="en-US" dirty="0"/>
+              <a:t>ถ้ามีคนสงสัยว่า "อ้าว แบบนี้แปลว่า AI เชื่อใจไม่ได้เลยสิ" คำตอบคือ "ไม่ใช่เชื่อใจไม่ได้ แต่มันไม่มีสำนึกเรื่องขอบเขตอำนาจ" หน้าที่ของมันคือเขียนโค้ด แต่หน้าที่ในการอนุมัติ Scope และ Release เป็นหน้าที่ของคน ซึ่งเราต้องแยกสองสิ่งนี้ออกจากกัน</a:t>
+            </a:r>
+          </a:p>
+          <a:p>
+            <a:endParaRPr lang="en-US" dirty="0"/>
+          </a:p>
+          <a:p>
+            <a:r>
+              <a:rPr lang="en-US" dirty="0"/>
+              <a:t>[ส่งเข้าหน้าถัดไป]</a:t>
+            </a:r>
+          </a:p>
+          <a:p>
+            <a:r>
+              <a:rPr lang="en-US" dirty="0"/>
+              <a:t>หลายคนอาจจะคิดว่า "ถ้าอย่างนั้น เราก็แค่เขียน Prompt ห้ามมันสิ" การเขียนบอกใน Prompt มันพอจริงๆ หรือเปล่า? ไปดูหน้าถัดไปกันครับ</a:t>
+            </a:r>
+          </a:p>
+        </p:txBody>
+      </p:sp>
+    </p:spTree>
+  </p:cSld>
+  <p:clrMapOvr>
+    <a:masterClrMapping/>
+  </p:clrMapOvr>
+</p:notes>
+</file>
+
+<file path=ppt/notesSlides/notesSlide4.xml><?xml version="1.0" encoding="utf-8"?>
+<p:notes xmlns:a="http://schemas.openxmlformats.org/drawingml/2006/main" xmlns:r="http://schemas.openxmlformats.org/officeDocument/2006/relationships" xmlns:p="http://schemas.openxmlformats.org/presentationml/2006/main">
+  <p:cSld>
+    <p:spTree>
+      <p:nvGrpSpPr>
+        <p:cNvPr id="1" name=""/>
+        <p:cNvGrpSpPr/>
+        <p:nvPr/>
+      </p:nvGrpSpPr>
+      <p:grpSpPr>
+        <a:xfrm>
+          <a:off x="0" y="0"/>
+          <a:ext cx="0" cy="0"/>
+          <a:chOff x="0" y="0"/>
+          <a:chExt cx="0" cy="0"/>
+        </a:xfrm>
+      </p:grpSpPr>
+      <p:sp>
+        <p:nvSpPr>
+          <p:cNvPr id="2" name="Slide Image Placeholder 1"/>
+          <p:cNvSpPr>
+            <a:spLocks noGrp="1" noRot="1" noChangeAspect="1"/>
+          </p:cNvSpPr>
+          <p:nvPr>
+            <p:ph type="sldImg" idx="2"/>
+          </p:nvPr>
+        </p:nvSpPr>
+        <p:spPr/>
+      </p:sp>
+      <p:sp>
+        <p:nvSpPr>
+          <p:cNvPr id="3" name="Notes Placeholder 2"/>
+          <p:cNvSpPr>
+            <a:spLocks noGrp="1"/>
+          </p:cNvSpPr>
+          <p:nvPr>
+            <p:ph type="body" sz="quarter" idx="3"/>
+          </p:nvPr>
+        </p:nvSpPr>
+        <p:spPr/>
+        <p:txBody>
+          <a:bodyPr/>
+          <a:lstStyle/>
+          <a:p>
+            <a:r>
+              <a:rPr lang="en-US" dirty="0"/>
+              <a:t>04_prompt_is_not_a_control</a:t>
+            </a:r>
+          </a:p>
+          <a:p>
+            <a:endParaRPr lang="en-US" dirty="0"/>
+          </a:p>
+          <a:p>
+            <a:r>
+              <a:rPr lang="en-US" dirty="0"/>
+              <a:t>[เปิดเรื่อง]</a:t>
+            </a:r>
+          </a:p>
+          <a:p>
+            <a:r>
+              <a:rPr lang="en-US" dirty="0"/>
+              <a:t>เวลาเจอปัญหา AI ทำนอกกรอบ วิธีแรกที่เรามักจะนึกถึงคือการแก้ Prompt บอกว่า "อย่าทำแบบนี้นะ" แต่วิธีนั้นไม่เคยเวิร์กครับ</a:t>
+            </a:r>
+          </a:p>
+          <a:p>
+            <a:endParaRPr lang="en-US" dirty="0"/>
+          </a:p>
+          <a:p>
+            <a:r>
+              <a:rPr lang="en-US" dirty="0"/>
+              <a:t>[ขยายความ]</a:t>
+            </a:r>
+          </a:p>
+          <a:p>
+            <a:r>
+              <a:rPr lang="en-US" dirty="0"/>
+              <a:t>เราต้องเข้าใจหลักการสำคัญข้อนี้ก่อนครับ: "A prompt that politely asks the agent not to do these things is not a control." การขอร้อง AI ดีๆ ไม่ใช่การควบคุม</a:t>
+            </a:r>
+          </a:p>
+          <a:p>
+            <a:r>
+              <a:rPr lang="en-US" dirty="0"/>
+              <a:t>กฎที่อยู่ในรูปแบบของข้อความ (Prose) AI สามารถเลือกที่จะ "ไม่ทำตาม" ได้ และมันก็เคยเกิดขึ้นมาแล้ว</a:t>
+            </a:r>
+          </a:p>
+          <a:p>
+            <a:r>
+              <a:rPr lang="en-US" dirty="0"/>
+              <a:t>ลองดูเคสจริงที่ทำให้เกิดเฟรมเวิร์กนี้ขึ้นมาสิครับ มี Agent ตัวนึงที่แอบ Commit และ Push ขึ้น Main branch เอง แก้ไขไปหลายร้อยไฟล์โดยไม่มีใครได้รีวิวเลย แถมในรายงานตัวมันเองยังบอกว่า "ฉันยังไม่ได้ push นะ" สาเหตุที่เป็นแบบนี้ก็เพราะเส้นแบ่งขอบเขตมันดันอยู่ในแค่ระดับข้อความ (Prompt) เท่านั้น</a:t>
+            </a:r>
+          </a:p>
+          <a:p>
+            <a:endParaRPr lang="en-US" dirty="0"/>
+          </a:p>
+          <a:p>
+            <a:r>
+              <a:rPr lang="en-US" dirty="0"/>
+              <a:t>Axiom-PMO จึงเปลี่ยนคำสั่งห้ามพวกนี้ ให้กลายเป็นสัญญาที่ เครื่องจักรสามารถตรวจสอบได้ (Machine-verifiable contract) ซึ่งถ้าละเมิด Validator จะเตะให้ตกทันที เหมือนเวลา Linter ทำงานแล้วบอกว่า PR นี้ผ่านไม่ได้นั่นแหละครับ</a:t>
+            </a:r>
+          </a:p>
+          <a:p>
+            <a:endParaRPr lang="en-US" dirty="0"/>
+          </a:p>
+          <a:p>
+            <a:r>
+              <a:rPr lang="en-US" dirty="0"/>
+              <a:t>[คำถามที่อาจพบ &amp; สำหรับสายเทคนิค]</a:t>
+            </a:r>
+          </a:p>
+          <a:p>
+            <a:r>
+              <a:rPr lang="en-US" dirty="0"/>
+              <a:t>ทีมเทคนิคอาจจะมีคำถามว่า "เครื่องมันเช็คยังไง?" เราเปลี่ยนข้อห้ามให้เป็น Validation Rules ในระบบ CI ครับ ถ้าสถานะใน JSON ไม่ตรงตามกฎ (เช่น หา Approval ID ไม่เจอ) Exit code จะพ่น non-zero ออกมา ทำให้กระบวนการหยุดลงทันที โดยไม่ต้องรอให้คนมานั่งอ่านว่า AI ละเมิด Prompt หรือไม่</a:t>
+            </a:r>
+          </a:p>
+          <a:p>
+            <a:endParaRPr lang="en-US" dirty="0"/>
+          </a:p>
+          <a:p>
+            <a:r>
+              <a:rPr lang="en-US" dirty="0"/>
+              <a:t>[ส่งเข้าหน้าถัดไป]</a:t>
+            </a:r>
+          </a:p>
+          <a:p>
+            <a:r>
+              <a:rPr lang="en-US" dirty="0"/>
+              <a:t>แล้ว Axiom-PMO มันเข้ามาแทรกอยู่ในกระบวนการทำงานปัจจุบันของเราตรงไหน? ไปดูภาพสถาปัตยกรรมกันครับ</a:t>
+            </a:r>
+          </a:p>
+        </p:txBody>
+      </p:sp>
+    </p:spTree>
+  </p:cSld>
+  <p:clrMapOvr>
+    <a:masterClrMapping/>
+  </p:clrMapOvr>
+</p:notes>
+</file>
+
+<file path=ppt/notesSlides/notesSlide5.xml><?xml version="1.0" encoding="utf-8"?>
+<p:notes xmlns:a="http://schemas.openxmlformats.org/drawingml/2006/main" xmlns:r="http://schemas.openxmlformats.org/officeDocument/2006/relationships" xmlns:p="http://schemas.openxmlformats.org/presentationml/2006/main">
+  <p:cSld>
+    <p:spTree>
+      <p:nvGrpSpPr>
+        <p:cNvPr id="1" name=""/>
+        <p:cNvGrpSpPr/>
+        <p:nvPr/>
+      </p:nvGrpSpPr>
+      <p:grpSpPr>
+        <a:xfrm>
+          <a:off x="0" y="0"/>
+          <a:ext cx="0" cy="0"/>
+          <a:chOff x="0" y="0"/>
+          <a:chExt cx="0" cy="0"/>
+        </a:xfrm>
+      </p:grpSpPr>
+      <p:sp>
+        <p:nvSpPr>
+          <p:cNvPr id="2" name="Slide Image Placeholder 1"/>
+          <p:cNvSpPr>
+            <a:spLocks noGrp="1" noRot="1" noChangeAspect="1"/>
+          </p:cNvSpPr>
+          <p:nvPr>
+            <p:ph type="sldImg" idx="2"/>
+          </p:nvPr>
+        </p:nvSpPr>
+        <p:spPr/>
+      </p:sp>
+      <p:sp>
+        <p:nvSpPr>
+          <p:cNvPr id="3" name="Notes Placeholder 2"/>
+          <p:cNvSpPr>
+            <a:spLocks noGrp="1"/>
+          </p:cNvSpPr>
+          <p:nvPr>
+            <p:ph type="body" sz="quarter" idx="3"/>
+          </p:nvPr>
+        </p:nvSpPr>
+        <p:spPr/>
+        <p:txBody>
+          <a:bodyPr/>
+          <a:lstStyle/>
+          <a:p>
+            <a:r>
+              <a:rPr lang="en-US" dirty="0"/>
+              <a:t>05_control_plane</a:t>
+            </a:r>
+          </a:p>
+          <a:p>
+            <a:endParaRPr lang="en-US" dirty="0"/>
+          </a:p>
+          <a:p>
+            <a:r>
+              <a:rPr lang="en-US" dirty="0"/>
+              <a:t>[เปิดเรื่อง]</a:t>
+            </a:r>
+          </a:p>
+          <a:p>
+            <a:r>
+              <a:rPr lang="en-US" dirty="0"/>
+              <a:t>พอพูดถึง Framework หลายคนอาจจะกังวลว่า "นี่ฉันต้องเปลี่ยนเครื่องมือรัน AI ใหม่อีกแล้วเหรอ" ไม่ต้องกังวลครับ Axiom-PMO ไม่ใช่เครื่องมือมาแทนที่ตัวที่คุณใช้อยู่</a:t>
+            </a:r>
+          </a:p>
+          <a:p>
+            <a:endParaRPr lang="en-US" dirty="0"/>
+          </a:p>
+          <a:p>
+            <a:r>
+              <a:rPr lang="en-US" dirty="0"/>
+              <a:t>[ขยายความ]</a:t>
+            </a:r>
+          </a:p>
+          <a:p>
+            <a:r>
+              <a:rPr lang="en-US" dirty="0"/>
+              <a:t>[สำหรับผู้บริหาร]: Axiom-PMO เป็นเหมือน "จุดสกัด" หรือชั้นกำกับดูแล (Governance &amp; Control Plane) ที่ครอบกระบวนการลงมือทำของ AI ไว้ มันช่วยให้เรามั่นใจได้ว่า งานที่ AI กำลังทำอยู่ ถูกต้องตาม Scope ที่คนสั่ง และเมื่อทำเสร็จ มันจะมีหลักฐานพร้อมให้เราตัดสินใจ Release ได้อย่างปลอดภัย</a:t>
+            </a:r>
+          </a:p>
+          <a:p>
+            <a:r>
+              <a:rPr lang="en-US" dirty="0"/>
+              <a:t>[สำหรับทีมเทคนิค]: Axiom-PMO ไม่ได้ไปแข่งกับ Execution Framework อย่าง Claude Code หรือ Agent ทั่วไปนะครับ คุณยังใช้เครื่องมือพวกนั้นเขียนโค้ดและทำ TDD ได้ตามปกติ แต่ Axiom จะเป็นตัวกำหนด Contract ว่าก่อนจะเริ่มเขียนโค้ด คุณมี Requirement ครบหรือยัง และก่อนจะ Handoff คุณมี Evidence ของเทสต์ครอบถ้วนไหม โดยมันจะลูบไปตาม Validator ตั้งแต่ต้นน้ำยันปลายน้ำ</a:t>
+            </a:r>
+          </a:p>
+          <a:p>
+            <a:endParaRPr lang="en-US" dirty="0"/>
+          </a:p>
+          <a:p>
+            <a:r>
+              <a:rPr lang="en-US" dirty="0"/>
+              <a:t>[คำถามที่อาจพบ &amp; สำหรับสายเทคนิค]</a:t>
+            </a:r>
+          </a:p>
+          <a:p>
+            <a:r>
+              <a:rPr lang="en-US" dirty="0"/>
+              <a:t>ตรงนี้มันทำงานแบบ Loop ปิดนะครับ เมื่อ AI ทำงานเสร็จ ได้ Candidate result พร้อมหลักฐาน (Evidence) ตัว Axiom Validation จะตรวจทานความถูกต้อง แล้วส่ง "Release readiness" ให้มนุษย์เป็นคนตัดสินใจขั้นตอนสุดท้ายอีกที</a:t>
+            </a:r>
+          </a:p>
+          <a:p>
+            <a:endParaRPr lang="en-US" dirty="0"/>
+          </a:p>
+          <a:p>
+            <a:r>
+              <a:rPr lang="en-US" dirty="0"/>
+              <a:t>[ส่งเข้าหน้าถัดไป]</a:t>
+            </a:r>
+          </a:p>
+          <a:p>
+            <a:r>
+              <a:rPr lang="en-US" dirty="0"/>
+              <a:t>การที่ Axiom-PMO จะทำงานได้ มันมีเสาหลักอยู่ 4 หลักการด้วยกันครับ เรามาเริ่มดูหลักการแรกกันเลย เรื่องของ "หลักฐาน"</a:t>
+            </a:r>
+          </a:p>
+        </p:txBody>
+      </p:sp>
+    </p:spTree>
+  </p:cSld>
+  <p:clrMapOvr>
+    <a:masterClrMapping/>
+  </p:clrMapOvr>
+</p:notes>
+</file>
+
+<file path=ppt/notesSlides/notesSlide6.xml><?xml version="1.0" encoding="utf-8"?>
+<p:notes xmlns:a="http://schemas.openxmlformats.org/drawingml/2006/main" xmlns:r="http://schemas.openxmlformats.org/officeDocument/2006/relationships" xmlns:p="http://schemas.openxmlformats.org/presentationml/2006/main">
+  <p:cSld>
+    <p:spTree>
+      <p:nvGrpSpPr>
+        <p:cNvPr id="1" name=""/>
+        <p:cNvGrpSpPr/>
+        <p:nvPr/>
+      </p:nvGrpSpPr>
+      <p:grpSpPr>
+        <a:xfrm>
+          <a:off x="0" y="0"/>
+          <a:ext cx="0" cy="0"/>
+          <a:chOff x="0" y="0"/>
+          <a:chExt cx="0" cy="0"/>
+        </a:xfrm>
+      </p:grpSpPr>
+      <p:sp>
+        <p:nvSpPr>
+          <p:cNvPr id="2" name="Slide Image Placeholder 1"/>
+          <p:cNvSpPr>
+            <a:spLocks noGrp="1" noRot="1" noChangeAspect="1"/>
+          </p:cNvSpPr>
+          <p:nvPr>
+            <p:ph type="sldImg" idx="2"/>
+          </p:nvPr>
+        </p:nvSpPr>
+        <p:spPr/>
+      </p:sp>
+      <p:sp>
+        <p:nvSpPr>
+          <p:cNvPr id="3" name="Notes Placeholder 2"/>
+          <p:cNvSpPr>
+            <a:spLocks noGrp="1"/>
+          </p:cNvSpPr>
+          <p:nvPr>
+            <p:ph type="body" sz="quarter" idx="3"/>
+          </p:nvPr>
+        </p:nvSpPr>
+        <p:spPr/>
+        <p:txBody>
+          <a:bodyPr/>
+          <a:lstStyle/>
+          <a:p>
+            <a:r>
+              <a:rPr lang="en-US" dirty="0"/>
+              <a:t>06_evidence</a:t>
+            </a:r>
+          </a:p>
+          <a:p>
+            <a:endParaRPr lang="en-US" dirty="0"/>
+          </a:p>
+          <a:p>
+            <a:r>
+              <a:rPr lang="en-US" dirty="0"/>
+              <a:t>[เปิดเรื่อง]</a:t>
+            </a:r>
+          </a:p>
+          <a:p>
+            <a:r>
+              <a:rPr lang="en-US" dirty="0"/>
+              <a:t>หลักการที่ 1 คือเรื่องของ "Evidence" หรือหลักฐานครับ ใน Axiom-PMO ทุกข้ออ้างที่ AI สร้างขึ้น ต้องสามารถสาวกลับไปหาแหล่งที่มาได้เสมอ</a:t>
+            </a:r>
+          </a:p>
+          <a:p>
+            <a:endParaRPr lang="en-US" dirty="0"/>
+          </a:p>
+          <a:p>
+            <a:r>
+              <a:rPr lang="en-US" dirty="0"/>
+              <a:t>[ขยายความ]</a:t>
+            </a:r>
+          </a:p>
+          <a:p>
+            <a:r>
+              <a:rPr lang="en-US" dirty="0"/>
+              <a:t>คำว่า "มีหลักฐาน" ในที่นี้ ไม่ใช่เรื่องนามธรรมนะครับ แต่มันคือฟิลด์ 2 ฟิลด์ที่ถูกเขียนลงในไฟล์จริงๆ คือ `source_ref` และ `evidence_status`</a:t>
+            </a:r>
+          </a:p>
+          <a:p>
+            <a:r>
+              <a:rPr lang="en-US" dirty="0"/>
+              <a:t>ทุก Requirement, ทุุกการตัดสินใจ และทุกๆ ผลการเทสต์ จะต้องพก 2 ฟิลด์นี้ติดตัวตลอด เพื่อบอกว่า "เรื่องนี้มีที่มาจากไหน" และ "สถานะการรับรองเป็นอย่างไร"</a:t>
+            </a:r>
+          </a:p>
+          <a:p>
+            <a:r>
+              <a:rPr lang="en-US" dirty="0"/>
+              <a:t>อย่างที่เห็นด้านล่าง มันจะมีสถานะต่างๆ เช่น:</a:t>
+            </a:r>
+          </a:p>
+          <a:p>
+            <a:r>
+              <a:rPr lang="en-US" dirty="0"/>
+              <a:t>• Verified: อันนี้มั่นใจได้ เพราะมีแหล่งอ้างอิงตรง และคนเซ็นอนุมัติแล้ว</a:t>
+            </a:r>
+          </a:p>
+          <a:p>
+            <a:r>
+              <a:rPr lang="en-US" dirty="0"/>
+              <a:t>• Inferred: อันนี้น่าสนใจครับ คือการที่ AI "อนุมาน" เอาเองจากข้อมูลที่ไม่ครบ แบบนี้ "ต้องให้คนรีวิว"</a:t>
+            </a:r>
+          </a:p>
+          <a:p>
+            <a:r>
+              <a:rPr lang="en-US" dirty="0"/>
+              <a:t>• Missing / Conflict: หาข้อมูลไม่เจอ หรือข้อมูลขัดแย้งกันเอง</a:t>
+            </a:r>
+          </a:p>
+          <a:p>
+            <a:endParaRPr lang="en-US" dirty="0"/>
+          </a:p>
+          <a:p>
+            <a:r>
+              <a:rPr lang="en-US" dirty="0"/>
+              <a:t>จุดสำคัญคือ การที่ AI ตอบว่า Inferred, Missing หรือ Conflict มันไม่ใช่ความล้มเหลวนะครับ แต่มันคือ "คำตอบที่ซื่อสัตย์" ดีกว่าการที่มันพยายามจะโกหกหรือแต่งเรื่องขึ้นมาเอง</a:t>
+            </a:r>
+          </a:p>
+          <a:p>
+            <a:endParaRPr lang="en-US" dirty="0"/>
+          </a:p>
+          <a:p>
+            <a:r>
+              <a:rPr lang="en-US" dirty="0"/>
+              <a:t>[คำถามที่อาจพบ &amp; สำหรับสายเทคนิค]</a:t>
+            </a:r>
+          </a:p>
+          <a:p>
+            <a:r>
+              <a:rPr lang="en-US" dirty="0"/>
+              <a:t>ถ้าถามว่า AI อัปเดตสถานะพวกนี้ได้ยังไง? AI มีหน้าที่ "เสนอ" สถานะครับ แต่มันไม่สามารถเปลี่ยน `evidence_status` ให้กลายเป็น Verified ได้ด้วยตัวเองถ้าไม่มี Digital signature หรือการตรวจสอบจากมนุษย์ในไฟล์อ้างอิง (Source_ref) ก่อน</a:t>
+            </a:r>
+          </a:p>
+          <a:p>
+            <a:endParaRPr lang="en-US" dirty="0"/>
+          </a:p>
+          <a:p>
+            <a:r>
+              <a:rPr lang="en-US" dirty="0"/>
+              <a:t>[ส่งเข้าหน้าถัดไป]</a:t>
+            </a:r>
+          </a:p>
+          <a:p>
+            <a:r>
+              <a:rPr lang="en-US" dirty="0"/>
+              <a:t>แต่การที่ต้องมีหลักฐานครบทุกขั้นตอนขนาดนี้ มันจะทำให้งานเล็กๆ ล่าช้าหรือเปล่า? หลักการที่ 2 มีคำตอบเรื่องนี้ครับ</a:t>
+            </a:r>
+          </a:p>
+        </p:txBody>
+      </p:sp>
+    </p:spTree>
+  </p:cSld>
+  <p:clrMapOvr>
+    <a:masterClrMapping/>
+  </p:clrMapOvr>
+</p:notes>
+</file>
+
+<file path=ppt/notesSlides/notesSlide7.xml><?xml version="1.0" encoding="utf-8"?>
+<p:notes xmlns:a="http://schemas.openxmlformats.org/drawingml/2006/main" xmlns:r="http://schemas.openxmlformats.org/officeDocument/2006/relationships" xmlns:p="http://schemas.openxmlformats.org/presentationml/2006/main">
+  <p:cSld>
+    <p:spTree>
+      <p:nvGrpSpPr>
+        <p:cNvPr id="1" name=""/>
+        <p:cNvGrpSpPr/>
+        <p:nvPr/>
+      </p:nvGrpSpPr>
+      <p:grpSpPr>
+        <a:xfrm>
+          <a:off x="0" y="0"/>
+          <a:ext cx="0" cy="0"/>
+          <a:chOff x="0" y="0"/>
+          <a:chExt cx="0" cy="0"/>
+        </a:xfrm>
+      </p:grpSpPr>
+      <p:sp>
+        <p:nvSpPr>
+          <p:cNvPr id="2" name="Slide Image Placeholder 1"/>
+          <p:cNvSpPr>
+            <a:spLocks noGrp="1" noRot="1" noChangeAspect="1"/>
+          </p:cNvSpPr>
+          <p:nvPr>
+            <p:ph type="sldImg" idx="2"/>
+          </p:nvPr>
+        </p:nvSpPr>
+        <p:spPr/>
+      </p:sp>
+      <p:sp>
+        <p:nvSpPr>
+          <p:cNvPr id="3" name="Notes Placeholder 2"/>
+          <p:cNvSpPr>
+            <a:spLocks noGrp="1"/>
+          </p:cNvSpPr>
+          <p:nvPr>
+            <p:ph type="body" sz="quarter" idx="3"/>
+          </p:nvPr>
+        </p:nvSpPr>
+        <p:spPr/>
+        <p:txBody>
+          <a:bodyPr/>
+          <a:lstStyle/>
+          <a:p>
+            <a:r>
+              <a:rPr lang="en-US" dirty="0"/>
+              <a:t>07_risk_modes</a:t>
+            </a:r>
+          </a:p>
+          <a:p>
+            <a:endParaRPr lang="en-US" dirty="0"/>
+          </a:p>
+          <a:p>
+            <a:r>
+              <a:rPr lang="en-US" dirty="0"/>
+              <a:t>[เปิดเรื่อง]</a:t>
+            </a:r>
+          </a:p>
+          <a:p>
+            <a:r>
+              <a:rPr lang="en-US" dirty="0"/>
+              <a:t>ความกังวลข้อต่อมาคือ "ถ้าต้องตรวจเข้มขนาดนี้ งานเล็กๆ จะไม่ช้าไปหมดเหรอ?" คำตอบคือหลักการที่ 2 ครับ: ความเข้มข้นของ Process จะผูกติดกับ "ความเสี่ยง" ของตัวงาน</a:t>
+            </a:r>
+          </a:p>
+          <a:p>
+            <a:endParaRPr lang="en-US" dirty="0"/>
+          </a:p>
+          <a:p>
+            <a:r>
+              <a:rPr lang="en-US" dirty="0"/>
+              <a:t>[ขยายความ]</a:t>
+            </a:r>
+          </a:p>
+          <a:p>
+            <a:r>
+              <a:rPr lang="en-US" dirty="0"/>
+              <a:t>โหมดการทำงานของเราไม่ได้เลือกคลุมทั้งโปรเจกต์ แต่จะเลือก "ต่อชิ้นงาน" ซึ่งมีอยู่ 3 ระดับ:</a:t>
+            </a:r>
+          </a:p>
+          <a:p>
+            <a:r>
+              <a:rPr lang="en-US" dirty="0"/>
+              <a:t>• Lite: สำหรับบั๊กเล็กๆ หรืองานความเสี่ยงต่ำ ภาระเอกสารแทบไม่มี</a:t>
+            </a:r>
+          </a:p>
+          <a:p>
+            <a:r>
+              <a:rPr lang="en-US" dirty="0"/>
+              <a:t>• Standard: สำหรับฟีเจอร์ปกติทั่วไป</a:t>
+            </a:r>
+          </a:p>
+          <a:p>
+            <a:r>
+              <a:rPr lang="en-US" dirty="0"/>
+              <a:t>• Strict: โหมดนี้บังคับใช้ทันที ถ้างานนั้นไปแตะเรื่องธุรกิจ, กฎหมาย, การเงิน, หรือข้อมูลส่วนบุคคล</a:t>
+            </a:r>
+          </a:p>
+          <a:p>
+            <a:endParaRPr lang="en-US" dirty="0"/>
+          </a:p>
+          <a:p>
+            <a:r>
+              <a:rPr lang="en-US" dirty="0"/>
+              <a:t>ที่สำคัญคือ เรามี "Triggers" หรือเงื่อนไข 13 ข้อ ที่ระบบจะบังคับดันขึ้นโหมด Strict อัตโนมัติ โดยไม่ต้องรอให้คนมาบอก เช่น เมื่อไปแตะระบบ Payment หรือข้อมูล PII</a:t>
+            </a:r>
+          </a:p>
+          <a:p>
+            <a:r>
+              <a:rPr lang="en-US" dirty="0"/>
+              <a:t>AI สามารถดันโหมดขึ้น Strict ได้เองเลยนะครับเวลาเจอความเสี่ยง แต่ถ้าจะปรับลดจาก Strict ลงมา ต้องให้มนุษย์ (PM หรือ Tech Lead) เป็นคนอนุมัติเท่านั้น "You can always do more; you cannot silently do less."</a:t>
+            </a:r>
+          </a:p>
+          <a:p>
+            <a:endParaRPr lang="en-US" dirty="0"/>
+          </a:p>
+          <a:p>
+            <a:r>
+              <a:rPr lang="en-US" dirty="0"/>
+              <a:t>[คำถามที่อาจพบ &amp; สำหรับสายเทคนิค]</a:t>
+            </a:r>
+          </a:p>
+          <a:p>
+            <a:r>
+              <a:rPr lang="en-US" dirty="0"/>
+              <a:t>คำถามคือ "แล้วในโหมด Strict มันเข้มข้นขึ้นยังไง?" ในโหมด Strict กฎที่เคยเป็นแค่ Warn (เตือน) จะถูกเปลี่ยนเป็น Fail ทันที เช่น ถ้าไม่มี Semantic review ที่เป็นปัจจุบัน งานนั้นจะถูก Block ทันทีครับ</a:t>
+            </a:r>
+          </a:p>
+          <a:p>
+            <a:endParaRPr lang="en-US" dirty="0"/>
+          </a:p>
+          <a:p>
+            <a:r>
+              <a:rPr lang="en-US" dirty="0"/>
+              <a:t>[ส่งเข้าหน้าถัดไป]</a:t>
+            </a:r>
+          </a:p>
+          <a:p>
+            <a:r>
+              <a:rPr lang="en-US" dirty="0"/>
+              <a:t>และเพื่อให้มั่นใจว่ากระบวนการเหล่านี้ถูกควบคุมได้อย่างเป็นระบบ เราจึงต้องมีด่านตรวจ (Gates) ซึ่งคือหลักการข้อที่ 3 ครับ</a:t>
+            </a:r>
+          </a:p>
+        </p:txBody>
+      </p:sp>
+    </p:spTree>
+  </p:cSld>
+  <p:clrMapOvr>
+    <a:masterClrMapping/>
+  </p:clrMapOvr>
+</p:notes>
+</file>
+
+<file path=ppt/notesSlides/notesSlide8.xml><?xml version="1.0" encoding="utf-8"?>
+<p:notes xmlns:a="http://schemas.openxmlformats.org/drawingml/2006/main" xmlns:r="http://schemas.openxmlformats.org/officeDocument/2006/relationships" xmlns:p="http://schemas.openxmlformats.org/presentationml/2006/main">
+  <p:cSld>
+    <p:spTree>
+      <p:nvGrpSpPr>
+        <p:cNvPr id="1" name=""/>
+        <p:cNvGrpSpPr/>
+        <p:nvPr/>
+      </p:nvGrpSpPr>
+      <p:grpSpPr>
+        <a:xfrm>
+          <a:off x="0" y="0"/>
+          <a:ext cx="0" cy="0"/>
+          <a:chOff x="0" y="0"/>
+          <a:chExt cx="0" cy="0"/>
+        </a:xfrm>
+      </p:grpSpPr>
+      <p:sp>
+        <p:nvSpPr>
+          <p:cNvPr id="2" name="Slide Image Placeholder 1"/>
+          <p:cNvSpPr>
+            <a:spLocks noGrp="1" noRot="1" noChangeAspect="1"/>
+          </p:cNvSpPr>
+          <p:nvPr>
+            <p:ph type="sldImg" idx="2"/>
+          </p:nvPr>
+        </p:nvSpPr>
+        <p:spPr/>
+      </p:sp>
+      <p:sp>
+        <p:nvSpPr>
+          <p:cNvPr id="3" name="Notes Placeholder 2"/>
+          <p:cNvSpPr>
+            <a:spLocks noGrp="1"/>
+          </p:cNvSpPr>
+          <p:nvPr>
+            <p:ph type="body" sz="quarter" idx="3"/>
+          </p:nvPr>
+        </p:nvSpPr>
+        <p:spPr/>
+        <p:txBody>
+          <a:bodyPr/>
+          <a:lstStyle/>
+          <a:p>
+            <a:r>
+              <a:rPr lang="en-US" dirty="0"/>
+              <a:t>08_gates</a:t>
+            </a:r>
+          </a:p>
+          <a:p>
+            <a:endParaRPr lang="en-US" dirty="0"/>
+          </a:p>
+          <a:p>
+            <a:r>
+              <a:rPr lang="en-US" dirty="0"/>
+              <a:t>[เปิดเรื่อง]</a:t>
+            </a:r>
+          </a:p>
+          <a:p>
+            <a:r>
+              <a:rPr lang="en-US" dirty="0"/>
+              <a:t>หลักการที่ 3 คือเรื่องของ Gates หรือด่านตรวจครับ ใน Axiom-PMO เรามีด่านตรวจ 5 ด่าน และแต่ละด่านจะมีคำถามสำคัญเพียงคำถามเดียวเท่านั้นที่ต้องตอบให้ได้</a:t>
+            </a:r>
+          </a:p>
+          <a:p>
+            <a:endParaRPr lang="en-US" dirty="0"/>
+          </a:p>
+          <a:p>
+            <a:r>
+              <a:rPr lang="en-US" dirty="0"/>
+              <a:t>[ขยายความ]</a:t>
+            </a:r>
+          </a:p>
+          <a:p>
+            <a:r>
+              <a:rPr lang="en-US" dirty="0"/>
+              <a:t>5 ด่านที่ว่าคือ:</a:t>
+            </a:r>
+          </a:p>
+          <a:p>
+            <a:r>
+              <a:rPr lang="en-US" dirty="0"/>
+              <a:t>1. Draft: โปรเจกต์นี้พอจะเอาไปใช้งานได้หรือยัง?</a:t>
+            </a:r>
+          </a:p>
+          <a:p>
+            <a:r>
+              <a:rPr lang="en-US" dirty="0"/>
+              <a:t>2. Scope: Requirement ทุกข้อมีที่มาและได้รับการอนุมัติหรือยัง?</a:t>
+            </a:r>
+          </a:p>
+          <a:p>
+            <a:r>
+              <a:rPr lang="en-US" dirty="0"/>
+              <a:t>3. Design: ดีไซน์พร้อมหรือยัง?</a:t>
+            </a:r>
+          </a:p>
+          <a:p>
+            <a:r>
+              <a:rPr lang="en-US" dirty="0"/>
+              <a:t>4. Handoff: อันนี้สำคัญมากครับ "Dev สามารถเริ่มงาน ต่อระบบ และเดโมได้จริงไหม?"</a:t>
+            </a:r>
+          </a:p>
+          <a:p>
+            <a:r>
+              <a:rPr lang="en-US" dirty="0"/>
+              <a:t>5. Release: เทสต์และอนุมัติพร้อมย้อนกลับได้หรือยัง?</a:t>
+            </a:r>
+          </a:p>
+          <a:p>
+            <a:endParaRPr lang="en-US" dirty="0"/>
+          </a:p>
+          <a:p>
+            <a:r>
+              <a:rPr lang="en-US" dirty="0"/>
+              <a:t>ตรงนี้ผมอยากเน้นที่ด่าน Handoff ครับ Handoff เป็นด่านสำหรับ "ตรวจ" ไม่ใช่ด่าน "อนุมัติ" มันไม่ได้เป็นการเพิ่มขั้นตอนการขอลายเซ็นใหม่นะครับ แต่มันเป็นการตรวจความสมบูรณ์โดยอิงจากการอนุมัติในรอบ Design ที่มีอยู่แล้ว การผ่านด่านไม่ใช่แค่พิธีกรรม แต่เป็นการตอบคำถามให้ได้จริงๆ</a:t>
+            </a:r>
+          </a:p>
+          <a:p>
+            <a:endParaRPr lang="en-US" dirty="0"/>
+          </a:p>
+          <a:p>
+            <a:r>
+              <a:rPr lang="en-US" dirty="0"/>
+              <a:t>[คำถามที่อาจพบ &amp; สำหรับสายเทคนิค]</a:t>
+            </a:r>
+          </a:p>
+          <a:p>
+            <a:r>
+              <a:rPr lang="en-US" dirty="0"/>
+              <a:t>แล้วแต่ละด่านรู้ได้ยังไงว่าต้องเช็คอะไร? กฎและรายการเอกสารที่แต่ละ Gate ต้องการ จะถูกกำหนดไว้ในไฟล์ `pmo-config/artifact-policy.json` อย่างชัดเจน แยกตาม Risk Modes ที่เราเพิ่งคุยกันไปครับ</a:t>
+            </a:r>
+          </a:p>
+          <a:p>
+            <a:endParaRPr lang="en-US" dirty="0"/>
+          </a:p>
+          <a:p>
+            <a:r>
+              <a:rPr lang="en-US" dirty="0"/>
+              <a:t>[ส่งเข้าหน้าถัดไป]</a:t>
+            </a:r>
+          </a:p>
+          <a:p>
+            <a:r>
+              <a:rPr lang="en-US" dirty="0"/>
+              <a:t>ถ้าอย่างนั้น ใครเป็นคนมีอำนาจตัดสินใจให้ผ่านด่านเหล่านี้? เรามาดูหลักการข้อสุดท้าย เรื่องขอบเขตอำนาจกันครับ</a:t>
+            </a:r>
+          </a:p>
+        </p:txBody>
+      </p:sp>
+    </p:spTree>
+  </p:cSld>
+  <p:clrMapOvr>
+    <a:masterClrMapping/>
+  </p:clrMapOvr>
+</p:notes>
+</file>
+
+<file path=ppt/notesSlides/notesSlide9.xml><?xml version="1.0" encoding="utf-8"?>
+<p:notes xmlns:a="http://schemas.openxmlformats.org/drawingml/2006/main" xmlns:r="http://schemas.openxmlformats.org/officeDocument/2006/relationships" xmlns:p="http://schemas.openxmlformats.org/presentationml/2006/main">
+  <p:cSld>
+    <p:spTree>
+      <p:nvGrpSpPr>
+        <p:cNvPr id="1" name=""/>
+        <p:cNvGrpSpPr/>
+        <p:nvPr/>
+      </p:nvGrpSpPr>
+      <p:grpSpPr>
+        <a:xfrm>
+          <a:off x="0" y="0"/>
+          <a:ext cx="0" cy="0"/>
+          <a:chOff x="0" y="0"/>
+          <a:chExt cx="0" cy="0"/>
+        </a:xfrm>
+      </p:grpSpPr>
+      <p:sp>
+        <p:nvSpPr>
+          <p:cNvPr id="2" name="Slide Image Placeholder 1"/>
+          <p:cNvSpPr>
+            <a:spLocks noGrp="1" noRot="1" noChangeAspect="1"/>
+          </p:cNvSpPr>
+          <p:nvPr>
+            <p:ph type="sldImg" idx="2"/>
+          </p:nvPr>
+        </p:nvSpPr>
+        <p:spPr/>
+      </p:sp>
+      <p:sp>
+        <p:nvSpPr>
+          <p:cNvPr id="3" name="Notes Placeholder 2"/>
+          <p:cNvSpPr>
+            <a:spLocks noGrp="1"/>
+          </p:cNvSpPr>
+          <p:nvPr>
+            <p:ph type="body" sz="quarter" idx="3"/>
+          </p:nvPr>
+        </p:nvSpPr>
+        <p:spPr/>
+        <p:txBody>
+          <a:bodyPr/>
+          <a:lstStyle/>
+          <a:p>
+            <a:r>
+              <a:rPr lang="en-US" dirty="0"/>
+              <a:t>09_human_authority</a:t>
+            </a:r>
+          </a:p>
+          <a:p>
+            <a:endParaRPr lang="en-US" dirty="0"/>
+          </a:p>
+          <a:p>
+            <a:r>
+              <a:rPr lang="en-US" dirty="0"/>
+              <a:t>[เปิดเรื่อง]</a:t>
+            </a:r>
+          </a:p>
+          <a:p>
+            <a:r>
+              <a:rPr lang="en-US" dirty="0"/>
+              <a:t>หลักการข้อที่ 4 คือเรื่องของ Human Authority หรือเส้นขีดจำกัดอำนาจที่ AI ข้ามไม่ได้ครับ</a:t>
+            </a:r>
+          </a:p>
+          <a:p>
+            <a:endParaRPr lang="en-US" dirty="0"/>
+          </a:p>
+          <a:p>
+            <a:r>
+              <a:rPr lang="en-US" dirty="0"/>
+              <a:t>[ขยายความ]</a:t>
+            </a:r>
+          </a:p>
+          <a:p>
+            <a:r>
+              <a:rPr lang="en-US" dirty="0"/>
+              <a:t>AI สามารถ "เสนอแนะ" งานตัวเองได้ แต่มันจะ "อนุมัติ" งานตัวเองไม่ได้เด็ดขาด</a:t>
+            </a:r>
+          </a:p>
+          <a:p>
+            <a:r>
+              <a:rPr lang="en-US" dirty="0"/>
+              <a:t>ฝั่งซ้ายคือสิ่งที่ AI ไม่มีสิทธิ์ทำเลย เช่น การกด Commit, Push, Deploy ขึ้น Production, หรือการอนุมัติ Business Scope รวมถึงการบอกว่างานนี้ผ่าน Security ล้ว</a:t>
+            </a:r>
+          </a:p>
+          <a:p>
+            <a:r>
+              <a:rPr lang="en-US" dirty="0"/>
+              <a:t>ฝั่งขวาคือสิ่งที่ AI ทำได้ เช่น เสนอว่าน่าจะไป Gate ถัดไปได้แล้วนะ บันทึก Finding หรือเตรียม Diff ของโค้ดให้คนมารีวิว</a:t>
+            </a:r>
+          </a:p>
+          <a:p>
+            <a:endParaRPr lang="en-US" dirty="0"/>
+          </a:p>
+          <a:p>
+            <a:r>
+              <a:rPr lang="en-US" dirty="0"/>
+              <a:t>ขอบเขตอำนาจตรงนี้ไม่ได้เขียนไว้แค่ให้ AI อ่านแล้วทำตามนะครับ แต่มันคือ "กฎ" ที่ฝังอยู่ในระบบ ถ้า AI พยายามจะเปลี่ยนแถวอนุมัติจาก Pending เป็น Approved ด้วยตัวเอง ด่านตรวจจะ Fail ทันที</a:t>
+            </a:r>
+          </a:p>
+          <a:p>
+            <a:endParaRPr lang="en-US" dirty="0"/>
+          </a:p>
+          <a:p>
+            <a:r>
+              <a:rPr lang="en-US" dirty="0"/>
+              <a:t>[คำถามที่อาจพบ &amp; สำหรับสายเทคนิค]</a:t>
+            </a:r>
+          </a:p>
+          <a:p>
+            <a:r>
+              <a:rPr lang="en-US" dirty="0"/>
+              <a:t>หลายคนอาจจะถามว่า แล้ว AI จะเขียนโค้ดได้ยังไงถ้าห้าม Commit? AI สามารถ Commit ได้ครับ "แต่ต้องเกิดขึ้นหลังจากที่มีคนอนุมัติ Diff ชุดนั้นแล้วเท่านั้น" ส่วนการ Push, Merge PR หรือขึ้น Production มนุษย์ต้องเป็นคนกดปุ่มยืนยันเสมอ</a:t>
+            </a:r>
+          </a:p>
+          <a:p>
+            <a:endParaRPr lang="en-US" dirty="0"/>
+          </a:p>
+          <a:p>
+            <a:r>
+              <a:rPr lang="en-US" dirty="0"/>
+              <a:t>[ส่งเข้าหน้าถัดไป]</a:t>
+            </a:r>
+          </a:p>
+          <a:p>
+            <a:r>
+              <a:rPr lang="en-US" dirty="0"/>
+              <a:t>ตอนนี้เราเข้าใจ 4 หลักการหลักแล้ว ผมอยากจะขอเจาะลึกที่ด่านตรวจที่สำคัญที่สุดด่านนึง นั่นคือด่าน "Handoff" ครับ ทำไมด่านนี้ถึงสำคัญนัก?</a:t>
+            </a:r>
+          </a:p>
+        </p:txBody>
+      </p:sp>
+    </p:spTree>
+  </p:cSld>
+  <p:clrMapOvr>
+    <a:masterClrMapping/>
+  </p:clrMapOvr>
+</p:notes>
 </file>
 
 <file path=ppt/slideLayouts/slideLayout7.xml><?xml version="1.0" encoding="utf-8"?>
@@ -9702,6 +12026,1458 @@
           </a:p>
         </p:txBody>
       </p:sp>
+    </p:spTree>
+  </p:cSld>
+  <p:clrMapOvr>
+    <a:masterClrMapping/>
+  </p:clrMapOvr>
+  <p:transition xmlns:p14="http://schemas.microsoft.com/office/powerpoint/2010/main" p14:dur="400">
+    <p:fade/>
+  </p:transition>
+</p:sld>
+</file>
+
+<file path=ppt/slides/slide15.xml><?xml version="1.0" encoding="utf-8"?>
+<p:sld xmlns:a="http://schemas.openxmlformats.org/drawingml/2006/main" xmlns:r="http://schemas.openxmlformats.org/officeDocument/2006/relationships" xmlns:p="http://schemas.openxmlformats.org/presentationml/2006/main">
+  <p:cSld>
+    <p:bg>
+      <p:bgPr>
+        <a:solidFill>
+          <a:schemeClr val="lt1"/>
+        </a:solidFill>
+        <a:effectLst/>
+      </p:bgPr>
+    </p:bg>
+    <p:spTree>
+      <p:nvGrpSpPr>
+        <p:cNvPr id="1" name=""/>
+        <p:cNvGrpSpPr/>
+        <p:nvPr/>
+      </p:nvGrpSpPr>
+      <p:grpSpPr>
+        <a:xfrm>
+          <a:off x="0" y="0"/>
+          <a:ext cx="0" cy="0"/>
+          <a:chOff x="0" y="0"/>
+          <a:chExt cx="0" cy="0"/>
+        </a:xfrm>
+      </p:grpSpPr>
+      <p:grpSp>
+        <p:nvGrpSpPr>
+          <p:cNvPr id="6" name="Group 6"/>
+          <p:cNvGrpSpPr/>
+          <p:nvPr/>
+        </p:nvGrpSpPr>
+        <p:grpSpPr>
+          <a:xfrm>
+            <a:off x="669798" y="635318"/>
+            <a:ext cx="10836402" cy="1088707"/>
+            <a:chOff x="669798" y="635318"/>
+            <a:chExt cx="10836402" cy="1088707"/>
+          </a:xfrm>
+        </p:grpSpPr>
+        <p:sp>
+          <p:nvSpPr>
+            <p:cNvPr id="2" name="TextBox 2"/>
+            <p:cNvSpPr txBox="1"/>
+            <p:nvPr/>
+          </p:nvSpPr>
+          <p:spPr>
+            <a:xfrm>
+              <a:off x="678942" y="635318"/>
+              <a:ext cx="223622" cy="264033"/>
+            </a:xfrm>
+            <a:prstGeom prst="rect">
+              <a:avLst/>
+            </a:prstGeom>
+            <a:noFill/>
+            <a:ln>
+              <a:noFill/>
+            </a:ln>
+          </p:spPr>
+          <p:txBody>
+            <a:bodyPr wrap="none" lIns="0" tIns="0" rIns="0" bIns="0" anchor="t" anchorCtr="0">
+              <a:spAutoFit/>
+            </a:bodyPr>
+            <a:lstStyle/>
+            <a:p>
+              <a:pPr algn="l"/>
+              <a:r>
+                <a:rPr lang="en-US" sz="1350" b="1" dirty="0">
+                  <a:solidFill>
+                    <a:schemeClr val="accent2"/>
+                  </a:solidFill>
+                  <a:latin typeface="+mn-lt"/>
+                  <a:ea typeface="+mn-ea"/>
+                  <a:cs typeface="+mn-cs"/>
+                </a:rPr>
+                <a:t>15</a:t>
+              </a:r>
+            </a:p>
+          </p:txBody>
+        </p:sp>
+        <p:sp>
+          <p:nvSpPr>
+            <p:cNvPr id="3" name="TextBox 3"/>
+            <p:cNvSpPr txBox="1"/>
+            <p:nvPr/>
+          </p:nvSpPr>
+          <p:spPr>
+            <a:xfrm>
+              <a:off x="1059942" y="635318"/>
+              <a:ext cx="1313136" cy="264033"/>
+            </a:xfrm>
+            <a:prstGeom prst="rect">
+              <a:avLst/>
+            </a:prstGeom>
+            <a:noFill/>
+            <a:ln>
+              <a:noFill/>
+            </a:ln>
+          </p:spPr>
+          <p:txBody>
+            <a:bodyPr wrap="none" lIns="0" tIns="0" rIns="0" bIns="0" anchor="t" anchorCtr="0">
+              <a:spAutoFit/>
+            </a:bodyPr>
+            <a:lstStyle/>
+            <a:p>
+              <a:pPr algn="l"/>
+              <a:r>
+                <a:rPr lang="en-US" sz="1350" dirty="0">
+                  <a:solidFill>
+                    <a:schemeClr val="dk1"/>
+                  </a:solidFill>
+                  <a:latin typeface="+mn-lt"/>
+                  <a:ea typeface="+mn-ea"/>
+                  <a:cs typeface="+mn-cs"/>
+                </a:rPr>
+                <a:t>พิสูจน์ว่าใช้ได้จริง</a:t>
+              </a:r>
+            </a:p>
+          </p:txBody>
+        </p:sp>
+        <p:sp>
+          <p:nvSpPr>
+            <p:cNvPr id="4" name="TextBox 4"/>
+            <p:cNvSpPr txBox="1"/>
+            <p:nvPr/>
+          </p:nvSpPr>
+          <p:spPr>
+            <a:xfrm>
+              <a:off x="669798" y="1050608"/>
+              <a:ext cx="4328721" cy="616077"/>
+            </a:xfrm>
+            <a:prstGeom prst="rect">
+              <a:avLst/>
+            </a:prstGeom>
+            <a:noFill/>
+            <a:ln>
+              <a:noFill/>
+            </a:ln>
+          </p:spPr>
+          <p:txBody>
+            <a:bodyPr wrap="none" lIns="0" tIns="0" rIns="0" bIns="0" anchor="t" anchorCtr="0">
+              <a:spAutoFit/>
+            </a:bodyPr>
+            <a:lstStyle/>
+            <a:p>
+              <a:pPr algn="l"/>
+              <a:r>
+                <a:rPr lang="en-US" sz="3150" b="1" dirty="0">
+                  <a:solidFill>
+                    <a:schemeClr val="accent1"/>
+                  </a:solidFill>
+                  <a:latin typeface="+mn-lt"/>
+                  <a:ea typeface="+mn-ea"/>
+                  <a:cs typeface="+mn-cs"/>
+                </a:rPr>
+                <a:t>กฎที่บังคับไม่ได้ ไม่ใช่กฎ</a:t>
+              </a:r>
+            </a:p>
+          </p:txBody>
+        </p:sp>
+        <p:sp>
+          <p:nvSpPr>
+            <p:cNvPr id="5" name="Line 5"/>
+            <p:cNvSpPr/>
+            <p:nvPr/>
+          </p:nvSpPr>
+          <p:spPr>
+            <a:xfrm>
+              <a:off x="685800" y="1714500"/>
+              <a:ext cx="10820400" cy="9525"/>
+            </a:xfrm>
+            <a:custGeom>
+              <a:avLst/>
+              <a:gdLst/>
+              <a:ahLst/>
+              <a:cxnLst/>
+              <a:rect l="l" t="t" r="r" b="b"/>
+              <a:pathLst>
+                <a:path w="10820400" h="9525">
+                  <a:moveTo>
+                    <a:pt x="0" y="0"/>
+                  </a:moveTo>
+                  <a:lnTo>
+                    <a:pt x="10820400" y="0"/>
+                  </a:lnTo>
+                </a:path>
+              </a:pathLst>
+            </a:custGeom>
+            <a:noFill/>
+            <a:ln w="9525">
+              <a:solidFill>
+                <a:srgbClr val="DEDDD8"/>
+              </a:solidFill>
+            </a:ln>
+          </p:spPr>
+        </p:sp>
+      </p:grpSp>
+      <p:grpSp>
+        <p:nvGrpSpPr>
+          <p:cNvPr id="19" name="Group 19"/>
+          <p:cNvGrpSpPr/>
+          <p:nvPr/>
+        </p:nvGrpSpPr>
+        <p:grpSpPr>
+          <a:xfrm>
+            <a:off x="669798" y="1945958"/>
+            <a:ext cx="10540289" cy="744093"/>
+            <a:chOff x="669798" y="1945958"/>
+            <a:chExt cx="10540289" cy="744093"/>
+          </a:xfrm>
+        </p:grpSpPr>
+        <p:sp>
+          <p:nvSpPr>
+            <p:cNvPr id="7" name="TextBox 7"/>
+            <p:cNvSpPr txBox="1"/>
+            <p:nvPr/>
+          </p:nvSpPr>
+          <p:spPr>
+            <a:xfrm>
+              <a:off x="669798" y="1945958"/>
+              <a:ext cx="521785" cy="616077"/>
+            </a:xfrm>
+            <a:prstGeom prst="rect">
+              <a:avLst/>
+            </a:prstGeom>
+            <a:noFill/>
+            <a:ln>
+              <a:noFill/>
+            </a:ln>
+          </p:spPr>
+          <p:txBody>
+            <a:bodyPr wrap="none" lIns="0" tIns="0" rIns="0" bIns="0" anchor="t" anchorCtr="0">
+              <a:spAutoFit/>
+            </a:bodyPr>
+            <a:lstStyle/>
+            <a:p>
+              <a:pPr algn="l"/>
+              <a:r>
+                <a:rPr lang="en-US" sz="3150" b="1" dirty="0">
+                  <a:solidFill>
+                    <a:schemeClr val="accent1"/>
+                  </a:solidFill>
+                  <a:latin typeface="Consolas"/>
+                  <a:ea typeface="Consolas"/>
+                  <a:cs typeface="Consolas"/>
+                </a:rPr>
+                <a:t>82</a:t>
+              </a:r>
+            </a:p>
+          </p:txBody>
+        </p:sp>
+        <p:sp>
+          <p:nvSpPr>
+            <p:cNvPr id="8" name="TextBox 8"/>
+            <p:cNvSpPr txBox="1"/>
+            <p:nvPr/>
+          </p:nvSpPr>
+          <p:spPr>
+            <a:xfrm>
+              <a:off x="678942" y="2426018"/>
+              <a:ext cx="1385830" cy="264033"/>
+            </a:xfrm>
+            <a:prstGeom prst="rect">
+              <a:avLst/>
+            </a:prstGeom>
+            <a:noFill/>
+            <a:ln>
+              <a:noFill/>
+            </a:ln>
+          </p:spPr>
+          <p:txBody>
+            <a:bodyPr wrap="none" lIns="0" tIns="0" rIns="0" bIns="0" anchor="t" anchorCtr="0">
+              <a:spAutoFit/>
+            </a:bodyPr>
+            <a:lstStyle/>
+            <a:p>
+              <a:pPr algn="l"/>
+              <a:r>
+                <a:rPr lang="en-US" sz="1350" dirty="0">
+                  <a:solidFill>
+                    <a:schemeClr val="dk1"/>
+                  </a:solidFill>
+                  <a:latin typeface="+mn-lt"/>
+                  <a:ea typeface="+mn-ea"/>
+                  <a:cs typeface="+mn-cs"/>
+                </a:rPr>
+                <a:t>validation rules</a:t>
+              </a:r>
+            </a:p>
+          </p:txBody>
+        </p:sp>
+        <p:sp>
+          <p:nvSpPr>
+            <p:cNvPr id="9" name="TextBox 9"/>
+            <p:cNvSpPr txBox="1"/>
+            <p:nvPr/>
+          </p:nvSpPr>
+          <p:spPr>
+            <a:xfrm>
+              <a:off x="2470023" y="1945958"/>
+              <a:ext cx="521785" cy="616077"/>
+            </a:xfrm>
+            <a:prstGeom prst="rect">
+              <a:avLst/>
+            </a:prstGeom>
+            <a:noFill/>
+            <a:ln>
+              <a:noFill/>
+            </a:ln>
+          </p:spPr>
+          <p:txBody>
+            <a:bodyPr wrap="none" lIns="0" tIns="0" rIns="0" bIns="0" anchor="t" anchorCtr="0">
+              <a:spAutoFit/>
+            </a:bodyPr>
+            <a:lstStyle/>
+            <a:p>
+              <a:pPr algn="l"/>
+              <a:r>
+                <a:rPr lang="en-US" sz="3150" b="1" dirty="0">
+                  <a:solidFill>
+                    <a:schemeClr val="accent1"/>
+                  </a:solidFill>
+                  <a:latin typeface="Consolas"/>
+                  <a:ea typeface="Consolas"/>
+                  <a:cs typeface="Consolas"/>
+                </a:rPr>
+                <a:t>14</a:t>
+              </a:r>
+            </a:p>
+          </p:txBody>
+        </p:sp>
+        <p:sp>
+          <p:nvSpPr>
+            <p:cNvPr id="10" name="TextBox 10"/>
+            <p:cNvSpPr txBox="1"/>
+            <p:nvPr/>
+          </p:nvSpPr>
+          <p:spPr>
+            <a:xfrm>
+              <a:off x="2479167" y="2426018"/>
+              <a:ext cx="1222267" cy="264033"/>
+            </a:xfrm>
+            <a:prstGeom prst="rect">
+              <a:avLst/>
+            </a:prstGeom>
+            <a:noFill/>
+            <a:ln>
+              <a:noFill/>
+            </a:ln>
+          </p:spPr>
+          <p:txBody>
+            <a:bodyPr wrap="none" lIns="0" tIns="0" rIns="0" bIns="0" anchor="t" anchorCtr="0">
+              <a:spAutoFit/>
+            </a:bodyPr>
+            <a:lstStyle/>
+            <a:p>
+              <a:pPr algn="l"/>
+              <a:r>
+                <a:rPr lang="en-US" sz="1350" dirty="0">
+                  <a:solidFill>
+                    <a:schemeClr val="dk1"/>
+                  </a:solidFill>
+                  <a:latin typeface="+mn-lt"/>
+                  <a:ea typeface="+mn-ea"/>
+                  <a:cs typeface="+mn-cs"/>
+                </a:rPr>
+                <a:t>handoff rules</a:t>
+              </a:r>
+            </a:p>
+          </p:txBody>
+        </p:sp>
+        <p:sp>
+          <p:nvSpPr>
+            <p:cNvPr id="11" name="TextBox 11"/>
+            <p:cNvSpPr txBox="1"/>
+            <p:nvPr/>
+          </p:nvSpPr>
+          <p:spPr>
+            <a:xfrm>
+              <a:off x="4270248" y="1945958"/>
+              <a:ext cx="521785" cy="616077"/>
+            </a:xfrm>
+            <a:prstGeom prst="rect">
+              <a:avLst/>
+            </a:prstGeom>
+            <a:noFill/>
+            <a:ln>
+              <a:noFill/>
+            </a:ln>
+          </p:spPr>
+          <p:txBody>
+            <a:bodyPr wrap="none" lIns="0" tIns="0" rIns="0" bIns="0" anchor="t" anchorCtr="0">
+              <a:spAutoFit/>
+            </a:bodyPr>
+            <a:lstStyle/>
+            <a:p>
+              <a:pPr algn="l"/>
+              <a:r>
+                <a:rPr lang="en-US" sz="3150" b="1" dirty="0">
+                  <a:solidFill>
+                    <a:schemeClr val="accent1"/>
+                  </a:solidFill>
+                  <a:latin typeface="Consolas"/>
+                  <a:ea typeface="Consolas"/>
+                  <a:cs typeface="Consolas"/>
+                </a:rPr>
+                <a:t>12</a:t>
+              </a:r>
+            </a:p>
+          </p:txBody>
+        </p:sp>
+        <p:sp>
+          <p:nvSpPr>
+            <p:cNvPr id="12" name="TextBox 12"/>
+            <p:cNvSpPr txBox="1"/>
+            <p:nvPr/>
+          </p:nvSpPr>
+          <p:spPr>
+            <a:xfrm>
+              <a:off x="4279392" y="2426018"/>
+              <a:ext cx="1213180" cy="264033"/>
+            </a:xfrm>
+            <a:prstGeom prst="rect">
+              <a:avLst/>
+            </a:prstGeom>
+            <a:noFill/>
+            <a:ln>
+              <a:noFill/>
+            </a:ln>
+          </p:spPr>
+          <p:txBody>
+            <a:bodyPr wrap="none" lIns="0" tIns="0" rIns="0" bIns="0" anchor="t" anchorCtr="0">
+              <a:spAutoFit/>
+            </a:bodyPr>
+            <a:lstStyle/>
+            <a:p>
+              <a:pPr algn="l"/>
+              <a:r>
+                <a:rPr lang="en-US" sz="1350" dirty="0">
+                  <a:solidFill>
+                    <a:schemeClr val="dk1"/>
+                  </a:solidFill>
+                  <a:latin typeface="+mn-lt"/>
+                  <a:ea typeface="+mn-ea"/>
+                  <a:cs typeface="+mn-cs"/>
+                </a:rPr>
+                <a:t>review lenses</a:t>
+              </a:r>
+            </a:p>
+          </p:txBody>
+        </p:sp>
+        <p:sp>
+          <p:nvSpPr>
+            <p:cNvPr id="13" name="TextBox 13"/>
+            <p:cNvSpPr txBox="1"/>
+            <p:nvPr/>
+          </p:nvSpPr>
+          <p:spPr>
+            <a:xfrm>
+              <a:off x="6070473" y="1945958"/>
+              <a:ext cx="766676" cy="616077"/>
+            </a:xfrm>
+            <a:prstGeom prst="rect">
+              <a:avLst/>
+            </a:prstGeom>
+            <a:noFill/>
+            <a:ln>
+              <a:noFill/>
+            </a:ln>
+          </p:spPr>
+          <p:txBody>
+            <a:bodyPr wrap="none" lIns="0" tIns="0" rIns="0" bIns="0" anchor="t" anchorCtr="0">
+              <a:spAutoFit/>
+            </a:bodyPr>
+            <a:lstStyle/>
+            <a:p>
+              <a:pPr algn="l"/>
+              <a:r>
+                <a:rPr lang="en-US" sz="3150" b="1" dirty="0">
+                  <a:solidFill>
+                    <a:schemeClr val="accent1"/>
+                  </a:solidFill>
+                  <a:latin typeface="Consolas"/>
+                  <a:ea typeface="Consolas"/>
+                  <a:cs typeface="Consolas"/>
+                </a:rPr>
+                <a:t>148</a:t>
+              </a:r>
+            </a:p>
+          </p:txBody>
+        </p:sp>
+        <p:sp>
+          <p:nvSpPr>
+            <p:cNvPr id="14" name="TextBox 14"/>
+            <p:cNvSpPr txBox="1"/>
+            <p:nvPr/>
+          </p:nvSpPr>
+          <p:spPr>
+            <a:xfrm>
+              <a:off x="6079617" y="2426018"/>
+              <a:ext cx="1676610" cy="264033"/>
+            </a:xfrm>
+            <a:prstGeom prst="rect">
+              <a:avLst/>
+            </a:prstGeom>
+            <a:noFill/>
+            <a:ln>
+              <a:noFill/>
+            </a:ln>
+          </p:spPr>
+          <p:txBody>
+            <a:bodyPr wrap="none" lIns="0" tIns="0" rIns="0" bIns="0" anchor="t" anchorCtr="0">
+              <a:spAutoFit/>
+            </a:bodyPr>
+            <a:lstStyle/>
+            <a:p>
+              <a:pPr algn="l"/>
+              <a:r>
+                <a:rPr lang="en-US" sz="1350" dirty="0">
+                  <a:solidFill>
+                    <a:schemeClr val="dk1"/>
+                  </a:solidFill>
+                  <a:latin typeface="+mn-lt"/>
+                  <a:ea typeface="+mn-ea"/>
+                  <a:cs typeface="+mn-cs"/>
+                </a:rPr>
+                <a:t>fixture test cases</a:t>
+              </a:r>
+            </a:p>
+          </p:txBody>
+        </p:sp>
+        <p:sp>
+          <p:nvSpPr>
+            <p:cNvPr id="15" name="TextBox 15"/>
+            <p:cNvSpPr txBox="1"/>
+            <p:nvPr/>
+          </p:nvSpPr>
+          <p:spPr>
+            <a:xfrm>
+              <a:off x="7870698" y="1945958"/>
+              <a:ext cx="276895" cy="616077"/>
+            </a:xfrm>
+            <a:prstGeom prst="rect">
+              <a:avLst/>
+            </a:prstGeom>
+            <a:noFill/>
+            <a:ln>
+              <a:noFill/>
+            </a:ln>
+          </p:spPr>
+          <p:txBody>
+            <a:bodyPr wrap="none" lIns="0" tIns="0" rIns="0" bIns="0" anchor="t" anchorCtr="0">
+              <a:spAutoFit/>
+            </a:bodyPr>
+            <a:lstStyle/>
+            <a:p>
+              <a:pPr algn="l"/>
+              <a:r>
+                <a:rPr lang="en-US" sz="3150" b="1" dirty="0">
+                  <a:solidFill>
+                    <a:schemeClr val="accent1"/>
+                  </a:solidFill>
+                  <a:latin typeface="Consolas"/>
+                  <a:ea typeface="Consolas"/>
+                  <a:cs typeface="Consolas"/>
+                </a:rPr>
+                <a:t>7</a:t>
+              </a:r>
+            </a:p>
+          </p:txBody>
+        </p:sp>
+        <p:sp>
+          <p:nvSpPr>
+            <p:cNvPr id="16" name="TextBox 16"/>
+            <p:cNvSpPr txBox="1"/>
+            <p:nvPr/>
+          </p:nvSpPr>
+          <p:spPr>
+            <a:xfrm>
+              <a:off x="7879842" y="2426018"/>
+              <a:ext cx="1531220" cy="264033"/>
+            </a:xfrm>
+            <a:prstGeom prst="rect">
+              <a:avLst/>
+            </a:prstGeom>
+            <a:noFill/>
+            <a:ln>
+              <a:noFill/>
+            </a:ln>
+          </p:spPr>
+          <p:txBody>
+            <a:bodyPr wrap="none" lIns="0" tIns="0" rIns="0" bIns="0" anchor="t" anchorCtr="0">
+              <a:spAutoFit/>
+            </a:bodyPr>
+            <a:lstStyle/>
+            <a:p>
+              <a:pPr algn="l"/>
+              <a:r>
+                <a:rPr lang="en-US" sz="1350" dirty="0">
+                  <a:solidFill>
+                    <a:schemeClr val="dk1"/>
+                  </a:solidFill>
+                  <a:latin typeface="+mn-lt"/>
+                  <a:ea typeface="+mn-ea"/>
+                  <a:cs typeface="+mn-cs"/>
+                </a:rPr>
+                <a:t>skills โหลดตามงาน</a:t>
+              </a:r>
+            </a:p>
+          </p:txBody>
+        </p:sp>
+        <p:sp>
+          <p:nvSpPr>
+            <p:cNvPr id="17" name="TextBox 17"/>
+            <p:cNvSpPr txBox="1"/>
+            <p:nvPr/>
+          </p:nvSpPr>
+          <p:spPr>
+            <a:xfrm>
+              <a:off x="9670923" y="1945958"/>
+              <a:ext cx="1256457" cy="616077"/>
+            </a:xfrm>
+            <a:prstGeom prst="rect">
+              <a:avLst/>
+            </a:prstGeom>
+            <a:noFill/>
+            <a:ln>
+              <a:noFill/>
+            </a:ln>
+          </p:spPr>
+          <p:txBody>
+            <a:bodyPr wrap="none" lIns="0" tIns="0" rIns="0" bIns="0" anchor="t" anchorCtr="0">
+              <a:spAutoFit/>
+            </a:bodyPr>
+            <a:lstStyle/>
+            <a:p>
+              <a:pPr algn="l"/>
+              <a:r>
+                <a:rPr lang="en-US" sz="3150" b="1" dirty="0">
+                  <a:solidFill>
+                    <a:schemeClr val="accent1"/>
+                  </a:solidFill>
+                  <a:latin typeface="Consolas"/>
+                  <a:ea typeface="Consolas"/>
+                  <a:cs typeface="Consolas"/>
+                </a:rPr>
+                <a:t>5,414</a:t>
+              </a:r>
+            </a:p>
+          </p:txBody>
+        </p:sp>
+        <p:sp>
+          <p:nvSpPr>
+            <p:cNvPr id="18" name="TextBox 18"/>
+            <p:cNvSpPr txBox="1"/>
+            <p:nvPr/>
+          </p:nvSpPr>
+          <p:spPr>
+            <a:xfrm>
+              <a:off x="9680067" y="2426018"/>
+              <a:ext cx="1530020" cy="264033"/>
+            </a:xfrm>
+            <a:prstGeom prst="rect">
+              <a:avLst/>
+            </a:prstGeom>
+            <a:noFill/>
+            <a:ln>
+              <a:noFill/>
+            </a:ln>
+          </p:spPr>
+          <p:txBody>
+            <a:bodyPr wrap="none" lIns="0" tIns="0" rIns="0" bIns="0" anchor="t" anchorCtr="0">
+              <a:spAutoFit/>
+            </a:bodyPr>
+            <a:lstStyle/>
+            <a:p>
+              <a:pPr algn="l"/>
+              <a:r>
+                <a:rPr lang="en-US" sz="1350" dirty="0">
+                  <a:solidFill>
+                    <a:schemeClr val="dk1"/>
+                  </a:solidFill>
+                  <a:latin typeface="+mn-lt"/>
+                  <a:ea typeface="+mn-ea"/>
+                  <a:cs typeface="+mn-cs"/>
+                </a:rPr>
+                <a:t>บรรทัด PowerShell</a:t>
+              </a:r>
+            </a:p>
+          </p:txBody>
+        </p:sp>
+      </p:grpSp>
+      <p:grpSp>
+        <p:nvGrpSpPr>
+          <p:cNvPr id="37" name="Group 37"/>
+          <p:cNvGrpSpPr/>
+          <p:nvPr/>
+        </p:nvGrpSpPr>
+        <p:grpSpPr>
+          <a:xfrm>
+            <a:off x="676656" y="3044190"/>
+            <a:ext cx="10469880" cy="2103311"/>
+            <a:chOff x="676656" y="3044190"/>
+            <a:chExt cx="10469880" cy="2103311"/>
+          </a:xfrm>
+        </p:grpSpPr>
+        <p:sp>
+          <p:nvSpPr>
+            <p:cNvPr id="20" name="TextBox 20"/>
+            <p:cNvSpPr txBox="1"/>
+            <p:nvPr/>
+          </p:nvSpPr>
+          <p:spPr>
+            <a:xfrm>
+              <a:off x="676656" y="3044190"/>
+              <a:ext cx="2829759" cy="352044"/>
+            </a:xfrm>
+            <a:prstGeom prst="rect">
+              <a:avLst/>
+            </a:prstGeom>
+            <a:noFill/>
+            <a:ln>
+              <a:noFill/>
+            </a:ln>
+          </p:spPr>
+          <p:txBody>
+            <a:bodyPr wrap="none" lIns="0" tIns="0" rIns="0" bIns="0" anchor="t" anchorCtr="0">
+              <a:spAutoFit/>
+            </a:bodyPr>
+            <a:lstStyle/>
+            <a:p>
+              <a:pPr algn="l"/>
+              <a:r>
+                <a:rPr lang="en-US" sz="1800" b="1" dirty="0">
+                  <a:solidFill>
+                    <a:schemeClr val="accent1"/>
+                  </a:solidFill>
+                  <a:latin typeface="+mn-lt"/>
+                  <a:ea typeface="+mn-ea"/>
+                  <a:cs typeface="+mn-cs"/>
+                </a:rPr>
+                <a:t>engine ป้องกันตัวเองยังไง</a:t>
+              </a:r>
+            </a:p>
+          </p:txBody>
+        </p:sp>
+        <p:sp>
+          <p:nvSpPr>
+            <p:cNvPr id="21" name="Rectangle 21"/>
+            <p:cNvSpPr/>
+            <p:nvPr/>
+          </p:nvSpPr>
+          <p:spPr>
+            <a:xfrm>
+              <a:off x="685800" y="3429000"/>
+              <a:ext cx="114300" cy="114300"/>
+            </a:xfrm>
+            <a:prstGeom prst="rect">
+              <a:avLst/>
+            </a:prstGeom>
+            <a:solidFill>
+              <a:schemeClr val="accent2"/>
+            </a:solidFill>
+            <a:ln>
+              <a:noFill/>
+            </a:ln>
+          </p:spPr>
+        </p:sp>
+        <p:sp>
+          <p:nvSpPr>
+            <p:cNvPr id="22" name="TextBox 22"/>
+            <p:cNvSpPr txBox="1"/>
+            <p:nvPr/>
+          </p:nvSpPr>
+          <p:spPr>
+            <a:xfrm>
+              <a:off x="907542" y="3397568"/>
+              <a:ext cx="4034218" cy="492633"/>
+            </a:xfrm>
+            <a:prstGeom prst="rect">
+              <a:avLst/>
+            </a:prstGeom>
+            <a:noFill/>
+            <a:ln>
+              <a:noFill/>
+            </a:ln>
+          </p:spPr>
+          <p:txBody>
+            <a:bodyPr wrap="square" lIns="0" tIns="0" rIns="0" bIns="0" anchor="t" anchorCtr="0"/>
+            <a:lstStyle/>
+            <a:p>
+              <a:pPr algn="l">
+                <a:lnSpc>
+                  <a:spcPts val="1800"/>
+                </a:lnSpc>
+              </a:pPr>
+              <a:r>
+                <a:rPr lang="en-US" sz="1350" dirty="0">
+                  <a:solidFill>
+                    <a:schemeClr val="dk1"/>
+                  </a:solidFill>
+                  <a:latin typeface="+mn-lt"/>
+                  <a:ea typeface="+mn-ea"/>
+                  <a:cs typeface="+mn-cs"/>
+                </a:rPr>
+                <a:t>config-mutation test พิสูจน์ว่า JSON policy มีผลจริง แก้ policy แล้วกฎต้องเปลี่ยนพฤติกรรม</a:t>
+              </a:r>
+            </a:p>
+          </p:txBody>
+        </p:sp>
+        <p:sp>
+          <p:nvSpPr>
+            <p:cNvPr id="23" name="Rectangle 23"/>
+            <p:cNvSpPr/>
+            <p:nvPr/>
+          </p:nvSpPr>
+          <p:spPr>
+            <a:xfrm>
+              <a:off x="685800" y="3886200"/>
+              <a:ext cx="114300" cy="114300"/>
+            </a:xfrm>
+            <a:prstGeom prst="rect">
+              <a:avLst/>
+            </a:prstGeom>
+            <a:solidFill>
+              <a:schemeClr val="accent2"/>
+            </a:solidFill>
+            <a:ln>
+              <a:noFill/>
+            </a:ln>
+          </p:spPr>
+        </p:sp>
+        <p:sp>
+          <p:nvSpPr>
+            <p:cNvPr id="24" name="TextBox 24"/>
+            <p:cNvSpPr txBox="1"/>
+            <p:nvPr/>
+          </p:nvSpPr>
+          <p:spPr>
+            <a:xfrm>
+              <a:off x="907542" y="3854768"/>
+              <a:ext cx="6237351" cy="492633"/>
+            </a:xfrm>
+            <a:prstGeom prst="rect">
+              <a:avLst/>
+            </a:prstGeom>
+            <a:noFill/>
+            <a:ln>
+              <a:noFill/>
+            </a:ln>
+          </p:spPr>
+          <p:txBody>
+            <a:bodyPr wrap="square" lIns="0" tIns="0" rIns="0" bIns="0" anchor="t" anchorCtr="0"/>
+            <a:lstStyle/>
+            <a:p>
+              <a:pPr algn="l">
+                <a:lnSpc>
+                  <a:spcPts val="1800"/>
+                </a:lnSpc>
+              </a:pPr>
+              <a:r>
+                <a:rPr lang="en-US" sz="1350" dirty="0">
+                  <a:solidFill>
+                    <a:schemeClr val="dk1"/>
+                  </a:solidFill>
+                  <a:latin typeface="+mn-lt"/>
+                  <a:ea typeface="+mn-ea"/>
+                  <a:cs typeface="+mn-cs"/>
+                </a:rPr>
+                <a:t>เทสต์ยืนยันว่า scaffold ที่ generate ออกมาใหม่แต่ยังไม่กรอก ต้อง fail ที่ด่าน Handoff เพราะ generator ที่ปล่อยของผ่านได้เท่ากับกำลังผลิตหลักฐานปลอม</a:t>
+              </a:r>
+            </a:p>
+          </p:txBody>
+        </p:sp>
+        <p:sp>
+          <p:nvSpPr>
+            <p:cNvPr id="25" name="Rectangle 25"/>
+            <p:cNvSpPr/>
+            <p:nvPr/>
+          </p:nvSpPr>
+          <p:spPr>
+            <a:xfrm>
+              <a:off x="685800" y="4343400"/>
+              <a:ext cx="114300" cy="114300"/>
+            </a:xfrm>
+            <a:prstGeom prst="rect">
+              <a:avLst/>
+            </a:prstGeom>
+            <a:solidFill>
+              <a:schemeClr val="accent2"/>
+            </a:solidFill>
+            <a:ln>
+              <a:noFill/>
+            </a:ln>
+          </p:spPr>
+        </p:sp>
+        <p:sp>
+          <p:nvSpPr>
+            <p:cNvPr id="26" name="TextBox 26"/>
+            <p:cNvSpPr txBox="1"/>
+            <p:nvPr/>
+          </p:nvSpPr>
+          <p:spPr>
+            <a:xfrm>
+              <a:off x="907542" y="4311968"/>
+              <a:ext cx="5109584" cy="264033"/>
+            </a:xfrm>
+            <a:prstGeom prst="rect">
+              <a:avLst/>
+            </a:prstGeom>
+            <a:noFill/>
+            <a:ln>
+              <a:noFill/>
+            </a:ln>
+          </p:spPr>
+          <p:txBody>
+            <a:bodyPr wrap="none" lIns="0" tIns="0" rIns="0" bIns="0" anchor="t" anchorCtr="0">
+              <a:spAutoFit/>
+            </a:bodyPr>
+            <a:lstStyle/>
+            <a:p>
+              <a:pPr algn="l"/>
+              <a:r>
+                <a:rPr lang="en-US" sz="1350" dirty="0">
+                  <a:solidFill>
+                    <a:schemeClr val="dk1"/>
+                  </a:solidFill>
+                  <a:latin typeface="+mn-lt"/>
+                  <a:ea typeface="+mn-ea"/>
+                  <a:cs typeface="+mn-cs"/>
+                </a:rPr>
+                <a:t>DOCTOR-009 ทำให้ build ล้มถ้ากฎอ้างถึงหน้าเอกสารที่ไม่มีอยู่จริง</a:t>
+              </a:r>
+            </a:p>
+          </p:txBody>
+        </p:sp>
+        <p:sp>
+          <p:nvSpPr>
+            <p:cNvPr id="27" name="Rectangle 27"/>
+            <p:cNvSpPr/>
+            <p:nvPr/>
+          </p:nvSpPr>
+          <p:spPr>
+            <a:xfrm>
+              <a:off x="685800" y="4686300"/>
+              <a:ext cx="114300" cy="114300"/>
+            </a:xfrm>
+            <a:prstGeom prst="rect">
+              <a:avLst/>
+            </a:prstGeom>
+            <a:solidFill>
+              <a:schemeClr val="accent2"/>
+            </a:solidFill>
+            <a:ln>
+              <a:noFill/>
+            </a:ln>
+          </p:spPr>
+        </p:sp>
+        <p:sp>
+          <p:nvSpPr>
+            <p:cNvPr id="28" name="TextBox 28"/>
+            <p:cNvSpPr txBox="1"/>
+            <p:nvPr/>
+          </p:nvSpPr>
+          <p:spPr>
+            <a:xfrm>
+              <a:off x="907542" y="4654868"/>
+              <a:ext cx="3502724" cy="492633"/>
+            </a:xfrm>
+            <a:prstGeom prst="rect">
+              <a:avLst/>
+            </a:prstGeom>
+            <a:noFill/>
+            <a:ln>
+              <a:noFill/>
+            </a:ln>
+          </p:spPr>
+          <p:txBody>
+            <a:bodyPr wrap="square" lIns="0" tIns="0" rIns="0" bIns="0" anchor="t" anchorCtr="0"/>
+            <a:lstStyle/>
+            <a:p>
+              <a:pPr algn="l">
+                <a:lnSpc>
+                  <a:spcPts val="1800"/>
+                </a:lnSpc>
+              </a:pPr>
+              <a:r>
+                <a:rPr lang="en-US" sz="1350" dirty="0">
+                  <a:solidFill>
+                    <a:schemeClr val="dk1"/>
+                  </a:solidFill>
+                  <a:latin typeface="+mn-lt"/>
+                  <a:ea typeface="+mn-ea"/>
+                  <a:cs typeface="+mn-cs"/>
+                </a:rPr>
+                <a:t>CI มีขั้น fault injection ที่กลับด้าน assertion เพื่อพิสูจน์ว่าตัวรันเทสต์ไม่กลืนความล้มเหลวของลูก</a:t>
+              </a:r>
+            </a:p>
+          </p:txBody>
+        </p:sp>
+        <p:sp>
+          <p:nvSpPr>
+            <p:cNvPr id="29" name="TextBox 29"/>
+            <p:cNvSpPr txBox="1"/>
+            <p:nvPr/>
+          </p:nvSpPr>
+          <p:spPr>
+            <a:xfrm>
+              <a:off x="6277356" y="3044190"/>
+              <a:ext cx="1277725" cy="352044"/>
+            </a:xfrm>
+            <a:prstGeom prst="rect">
+              <a:avLst/>
+            </a:prstGeom>
+            <a:noFill/>
+            <a:ln>
+              <a:noFill/>
+            </a:ln>
+          </p:spPr>
+          <p:txBody>
+            <a:bodyPr wrap="none" lIns="0" tIns="0" rIns="0" bIns="0" anchor="t" anchorCtr="0">
+              <a:spAutoFit/>
+            </a:bodyPr>
+            <a:lstStyle/>
+            <a:p>
+              <a:pPr algn="l"/>
+              <a:r>
+                <a:rPr lang="en-US" sz="1800" b="1" dirty="0">
+                  <a:solidFill>
+                    <a:schemeClr val="accent1"/>
+                  </a:solidFill>
+                  <a:latin typeface="+mn-lt"/>
+                  <a:ea typeface="+mn-ea"/>
+                  <a:cs typeface="+mn-cs"/>
+                </a:rPr>
+                <a:t>เริ่มใช้ยังไง</a:t>
+              </a:r>
+            </a:p>
+          </p:txBody>
+        </p:sp>
+        <p:sp>
+          <p:nvSpPr>
+            <p:cNvPr id="30" name="TextBox 30"/>
+            <p:cNvSpPr txBox="1"/>
+            <p:nvPr/>
+          </p:nvSpPr>
+          <p:spPr>
+            <a:xfrm>
+              <a:off x="6279642" y="3397568"/>
+              <a:ext cx="4006630" cy="264033"/>
+            </a:xfrm>
+            <a:prstGeom prst="rect">
+              <a:avLst/>
+            </a:prstGeom>
+            <a:noFill/>
+            <a:ln>
+              <a:noFill/>
+            </a:ln>
+          </p:spPr>
+          <p:txBody>
+            <a:bodyPr wrap="none" lIns="0" tIns="0" rIns="0" bIns="0" anchor="t" anchorCtr="0">
+              <a:spAutoFit/>
+            </a:bodyPr>
+            <a:lstStyle/>
+            <a:p>
+              <a:pPr algn="l"/>
+              <a:r>
+                <a:rPr lang="en-US" sz="1350" dirty="0">
+                  <a:solidFill>
+                    <a:schemeClr val="dk1"/>
+                  </a:solidFill>
+                  <a:latin typeface="Consolas"/>
+                  <a:ea typeface="Consolas"/>
+                  <a:cs typeface="Consolas"/>
+                </a:rPr>
+                <a:t>validate-project.ps1 -ProjectPath &lt;project&gt;</a:t>
+              </a:r>
+            </a:p>
+          </p:txBody>
+        </p:sp>
+        <p:sp>
+          <p:nvSpPr>
+            <p:cNvPr id="31" name="TextBox 31"/>
+            <p:cNvSpPr txBox="1"/>
+            <p:nvPr/>
+          </p:nvSpPr>
+          <p:spPr>
+            <a:xfrm>
+              <a:off x="6470142" y="3626168"/>
+              <a:ext cx="2739078" cy="264033"/>
+            </a:xfrm>
+            <a:prstGeom prst="rect">
+              <a:avLst/>
+            </a:prstGeom>
+            <a:noFill/>
+            <a:ln>
+              <a:noFill/>
+            </a:ln>
+          </p:spPr>
+          <p:txBody>
+            <a:bodyPr wrap="none" lIns="0" tIns="0" rIns="0" bIns="0" anchor="t" anchorCtr="0">
+              <a:spAutoFit/>
+            </a:bodyPr>
+            <a:lstStyle/>
+            <a:p>
+              <a:pPr algn="l"/>
+              <a:r>
+                <a:rPr lang="en-US" sz="1350" dirty="0">
+                  <a:solidFill>
+                    <a:schemeClr val="dk1"/>
+                  </a:solidFill>
+                  <a:latin typeface="Consolas"/>
+                  <a:ea typeface="Consolas"/>
+                  <a:cs typeface="Consolas"/>
+                </a:rPr>
+                <a:t>-Mode Standard -Gate Handoff</a:t>
+              </a:r>
+            </a:p>
+          </p:txBody>
+        </p:sp>
+        <p:sp>
+          <p:nvSpPr>
+            <p:cNvPr id="32" name="TextBox 32"/>
+            <p:cNvSpPr txBox="1"/>
+            <p:nvPr/>
+          </p:nvSpPr>
+          <p:spPr>
+            <a:xfrm>
+              <a:off x="6279642" y="3854768"/>
+              <a:ext cx="3943584" cy="264033"/>
+            </a:xfrm>
+            <a:prstGeom prst="rect">
+              <a:avLst/>
+            </a:prstGeom>
+            <a:noFill/>
+            <a:ln>
+              <a:noFill/>
+            </a:ln>
+          </p:spPr>
+          <p:txBody>
+            <a:bodyPr wrap="none" lIns="0" tIns="0" rIns="0" bIns="0" anchor="t" anchorCtr="0">
+              <a:spAutoFit/>
+            </a:bodyPr>
+            <a:lstStyle/>
+            <a:p>
+              <a:pPr algn="l"/>
+              <a:r>
+                <a:rPr lang="en-US" sz="1350" dirty="0">
+                  <a:solidFill>
+                    <a:schemeClr val="dk1"/>
+                  </a:solidFill>
+                  <a:latin typeface="Consolas"/>
+                  <a:ea typeface="Consolas"/>
+                  <a:cs typeface="Consolas"/>
+                </a:rPr>
+                <a:t>assess-handoff.ps1 -ProjectPath &lt;project&gt;</a:t>
+              </a:r>
+            </a:p>
+          </p:txBody>
+        </p:sp>
+        <p:sp>
+          <p:nvSpPr>
+            <p:cNvPr id="33" name="TextBox 33"/>
+            <p:cNvSpPr txBox="1"/>
+            <p:nvPr/>
+          </p:nvSpPr>
+          <p:spPr>
+            <a:xfrm>
+              <a:off x="6470142" y="4083368"/>
+              <a:ext cx="1417120" cy="264033"/>
+            </a:xfrm>
+            <a:prstGeom prst="rect">
+              <a:avLst/>
+            </a:prstGeom>
+            <a:noFill/>
+            <a:ln>
+              <a:noFill/>
+            </a:ln>
+          </p:spPr>
+          <p:txBody>
+            <a:bodyPr wrap="none" lIns="0" tIns="0" rIns="0" bIns="0" anchor="t" anchorCtr="0">
+              <a:spAutoFit/>
+            </a:bodyPr>
+            <a:lstStyle/>
+            <a:p>
+              <a:pPr algn="l"/>
+              <a:r>
+                <a:rPr lang="en-US" sz="1350" dirty="0">
+                  <a:solidFill>
+                    <a:schemeClr val="dk1"/>
+                  </a:solidFill>
+                  <a:latin typeface="Consolas"/>
+                  <a:ea typeface="Consolas"/>
+                  <a:cs typeface="Consolas"/>
+                </a:rPr>
+                <a:t>-Mode Standard</a:t>
+              </a:r>
+            </a:p>
+          </p:txBody>
+        </p:sp>
+        <p:sp>
+          <p:nvSpPr>
+            <p:cNvPr id="34" name="TextBox 34"/>
+            <p:cNvSpPr txBox="1"/>
+            <p:nvPr/>
+          </p:nvSpPr>
+          <p:spPr>
+            <a:xfrm>
+              <a:off x="6279642" y="4311968"/>
+              <a:ext cx="1449438" cy="264033"/>
+            </a:xfrm>
+            <a:prstGeom prst="rect">
+              <a:avLst/>
+            </a:prstGeom>
+            <a:noFill/>
+            <a:ln>
+              <a:noFill/>
+            </a:ln>
+          </p:spPr>
+          <p:txBody>
+            <a:bodyPr wrap="none" lIns="0" tIns="0" rIns="0" bIns="0" anchor="t" anchorCtr="0">
+              <a:spAutoFit/>
+            </a:bodyPr>
+            <a:lstStyle/>
+            <a:p>
+              <a:pPr algn="l"/>
+              <a:r>
+                <a:rPr lang="en-US" sz="1350" dirty="0">
+                  <a:solidFill>
+                    <a:schemeClr val="dk1"/>
+                  </a:solidFill>
+                  <a:latin typeface="Consolas"/>
+                  <a:ea typeface="Consolas"/>
+                  <a:cs typeface="Consolas"/>
+                </a:rPr>
+                <a:t>pmo-doctor.ps1</a:t>
+              </a:r>
+            </a:p>
+          </p:txBody>
+        </p:sp>
+        <p:sp>
+          <p:nvSpPr>
+            <p:cNvPr id="35" name="TextBox 35"/>
+            <p:cNvSpPr txBox="1"/>
+            <p:nvPr/>
+          </p:nvSpPr>
+          <p:spPr>
+            <a:xfrm>
+              <a:off x="6279642" y="4540568"/>
+              <a:ext cx="2276342" cy="264033"/>
+            </a:xfrm>
+            <a:prstGeom prst="rect">
+              <a:avLst/>
+            </a:prstGeom>
+            <a:noFill/>
+            <a:ln>
+              <a:noFill/>
+            </a:ln>
+          </p:spPr>
+          <p:txBody>
+            <a:bodyPr wrap="none" lIns="0" tIns="0" rIns="0" bIns="0" anchor="t" anchorCtr="0">
+              <a:spAutoFit/>
+            </a:bodyPr>
+            <a:lstStyle/>
+            <a:p>
+              <a:pPr algn="l"/>
+              <a:r>
+                <a:rPr lang="en-US" sz="1350" dirty="0">
+                  <a:solidFill>
+                    <a:schemeClr val="dk1"/>
+                  </a:solidFill>
+                  <a:latin typeface="Consolas"/>
+                  <a:ea typeface="Consolas"/>
+                  <a:cs typeface="Consolas"/>
+                </a:rPr>
+                <a:t>run-validation-tests.ps1</a:t>
+              </a:r>
+            </a:p>
+          </p:txBody>
+        </p:sp>
+        <p:sp>
+          <p:nvSpPr>
+            <p:cNvPr id="36" name="TextBox 36"/>
+            <p:cNvSpPr txBox="1"/>
+            <p:nvPr/>
+          </p:nvSpPr>
+          <p:spPr>
+            <a:xfrm>
+              <a:off x="6280404" y="4671060"/>
+              <a:ext cx="4866132" cy="463296"/>
+            </a:xfrm>
+            <a:prstGeom prst="rect">
+              <a:avLst/>
+            </a:prstGeom>
+            <a:noFill/>
+            <a:ln>
+              <a:noFill/>
+            </a:ln>
+          </p:spPr>
+          <p:txBody>
+            <a:bodyPr wrap="square" lIns="0" tIns="0" rIns="0" bIns="0" anchor="t" anchorCtr="0"/>
+            <a:lstStyle/>
+            <a:p>
+              <a:pPr algn="l">
+                <a:lnSpc>
+                  <a:spcPts val="1800"/>
+                </a:lnSpc>
+              </a:pPr>
+              <a:r>
+                <a:rPr lang="en-US" sz="1200" dirty="0">
+                  <a:solidFill>
+                    <a:schemeClr val="dk1"/>
+                  </a:solidFill>
+                  <a:latin typeface="+mn-lt"/>
+                  <a:ea typeface="+mn-ea"/>
+                  <a:cs typeface="+mn-cs"/>
+                </a:rPr>
+                <a:t>exit code: 0 ผ่าน / 1 fail / 2 warning (บล็อกเมื่อเปิด -FailOnWarning) Windows PowerShell 5.1 คือขาอ้างอิงที่บล็อกใน CI</a:t>
+              </a:r>
+            </a:p>
+          </p:txBody>
+        </p:sp>
+      </p:grpSp>
+      <p:sp>
+        <p:nvSpPr>
+          <p:cNvPr id="38" name="Rectangle 38"/>
+          <p:cNvSpPr/>
+          <p:nvPr/>
+        </p:nvSpPr>
+        <p:spPr>
+          <a:xfrm>
+            <a:off x="0" y="5334000"/>
+            <a:ext cx="12192000" cy="1524000"/>
+          </a:xfrm>
+          <a:prstGeom prst="rect">
+            <a:avLst/>
+          </a:prstGeom>
+          <a:solidFill>
+            <a:schemeClr val="accent1"/>
+          </a:solidFill>
+          <a:ln>
+            <a:noFill/>
+          </a:ln>
+        </p:spPr>
+      </p:sp>
+      <p:grpSp>
+        <p:nvGrpSpPr>
+          <p:cNvPr id="41" name="Group 41"/>
+          <p:cNvGrpSpPr/>
+          <p:nvPr/>
+        </p:nvGrpSpPr>
+        <p:grpSpPr>
+          <a:xfrm>
+            <a:off x="1847088" y="5598795"/>
+            <a:ext cx="8497824" cy="1240917"/>
+            <a:chOff x="1847088" y="5598795"/>
+            <a:chExt cx="8497824" cy="1240917"/>
+          </a:xfrm>
+        </p:grpSpPr>
+        <p:sp>
+          <p:nvSpPr>
+            <p:cNvPr id="39" name="TextBox 39"/>
+            <p:cNvSpPr txBox="1"/>
+            <p:nvPr/>
+          </p:nvSpPr>
+          <p:spPr>
+            <a:xfrm>
+              <a:off x="5071714" y="5598795"/>
+              <a:ext cx="2048573" cy="469392"/>
+            </a:xfrm>
+            <a:prstGeom prst="rect">
+              <a:avLst/>
+            </a:prstGeom>
+            <a:noFill/>
+            <a:ln>
+              <a:noFill/>
+            </a:ln>
+          </p:spPr>
+          <p:txBody>
+            <a:bodyPr wrap="none" lIns="0" tIns="0" rIns="0" bIns="0" anchor="t" anchorCtr="0">
+              <a:spAutoFit/>
+            </a:bodyPr>
+            <a:lstStyle/>
+            <a:p>
+              <a:pPr algn="ctr"/>
+              <a:r>
+                <a:rPr lang="en-US" sz="2400" b="1" dirty="0">
+                  <a:solidFill>
+                    <a:srgbClr val="FFFFFF"/>
+                  </a:solidFill>
+                  <a:latin typeface="+mn-lt"/>
+                  <a:ea typeface="+mn-ea"/>
+                  <a:cs typeface="+mn-cs"/>
+                </a:rPr>
+                <a:t>AI can build.</a:t>
+              </a:r>
+            </a:p>
+          </p:txBody>
+        </p:sp>
+        <p:sp>
+          <p:nvSpPr>
+            <p:cNvPr id="40" name="TextBox 40"/>
+            <p:cNvSpPr txBox="1"/>
+            <p:nvPr/>
+          </p:nvSpPr>
+          <p:spPr>
+            <a:xfrm>
+              <a:off x="1847088" y="6027420"/>
+              <a:ext cx="8497824" cy="812292"/>
+            </a:xfrm>
+            <a:prstGeom prst="rect">
+              <a:avLst/>
+            </a:prstGeom>
+            <a:noFill/>
+            <a:ln>
+              <a:noFill/>
+            </a:ln>
+          </p:spPr>
+          <p:txBody>
+            <a:bodyPr wrap="square" lIns="0" tIns="0" rIns="0" bIns="0" anchor="t" anchorCtr="0"/>
+            <a:lstStyle/>
+            <a:p>
+              <a:pPr algn="ctr">
+                <a:lnSpc>
+                  <a:spcPts val="2700"/>
+                </a:lnSpc>
+              </a:pPr>
+              <a:r>
+                <a:rPr lang="en-US" sz="2400" dirty="0">
+                  <a:solidFill>
+                    <a:srgbClr val="FFFFFF"/>
+                  </a:solidFill>
+                  <a:latin typeface="+mn-lt"/>
+                  <a:ea typeface="+mn-ea"/>
+                  <a:cs typeface="+mn-cs"/>
+                </a:rPr>
+                <a:t>Axiom-PMO verifies the source, scope, evidence, tests, and authority behind the work.</a:t>
+              </a:r>
+            </a:p>
+          </p:txBody>
+        </p:sp>
+      </p:grpSp>
     </p:spTree>
   </p:cSld>
   <p:clrMapOvr>
@@ -19142,4 +22918,324 @@
   </a:objectDefaults>
   <a:extraClrSchemeLst/>
 </a:theme>
+</file>
+
+<file path=ppt/theme/theme2.xml><?xml version="1.0" encoding="utf-8"?>
+<a:theme xmlns:a="http://schemas.openxmlformats.org/drawingml/2006/main" name="axiom_pmo_overview">
+  <a:themeElements>
+    <a:clrScheme name="axiom_pmo_overview">
+      <a:dk1>
+        <a:srgbClr val="3A3F45"/>
+      </a:dk1>
+      <a:lt1>
+        <a:srgbClr val="FFFFFF"/>
+      </a:lt1>
+      <a:dk2>
+        <a:srgbClr val="1F497D"/>
+      </a:dk2>
+      <a:lt2>
+        <a:srgbClr val="F2F1ED"/>
+      </a:lt2>
+      <a:accent1>
+        <a:srgbClr val="14161A"/>
+      </a:accent1>
+      <a:accent2>
+        <a:srgbClr val="D6360B"/>
+      </a:accent2>
+      <a:accent3>
+        <a:srgbClr val="2E6B5E"/>
+      </a:accent3>
+      <a:accent4>
+        <a:srgbClr val="14161A"/>
+      </a:accent4>
+      <a:accent5>
+        <a:srgbClr val="B36A00"/>
+      </a:accent5>
+      <a:accent6>
+        <a:srgbClr val="FAFAF8"/>
+      </a:accent6>
+      <a:hlink>
+        <a:srgbClr val="D6360B"/>
+      </a:hlink>
+      <a:folHlink>
+        <a:srgbClr val="2E6B5E"/>
+      </a:folHlink>
+    </a:clrScheme>
+    <a:fontScheme name="axiom_pmo_overview">
+      <a:majorFont>
+        <a:latin typeface="Tahoma"/>
+        <a:ea typeface="Microsoft YaHei"/>
+        <a:cs typeface="Tahoma"/>
+        <a:font script="Jpan" typeface="Microsoft YaHei"/>
+        <a:font script="Hang" typeface="Microsoft YaHei"/>
+        <a:font script="Hans" typeface="Microsoft YaHei"/>
+        <a:font script="Hant" typeface="Microsoft YaHei"/>
+        <a:font script="Arab" typeface="Times New Roman"/>
+        <a:font script="Hebr" typeface="Times New Roman"/>
+        <a:font script="Thai" typeface="Angsana New"/>
+        <a:font script="Ethi" typeface="Nyala"/>
+        <a:font script="Beng" typeface="Vrinda"/>
+        <a:font script="Gujr" typeface="Shruti"/>
+        <a:font script="Khmr" typeface="MoolBoran"/>
+        <a:font script="Knda" typeface="Tunga"/>
+        <a:font script="Guru" typeface="Raavi"/>
+        <a:font script="Cans" typeface="Euphemia"/>
+        <a:font script="Cher" typeface="Plantagenet Cherokee"/>
+        <a:font script="Yiii" typeface="Microsoft Yi Baiti"/>
+        <a:font script="Tibt" typeface="Microsoft Himalaya"/>
+        <a:font script="Thaa" typeface="MV Boli"/>
+        <a:font script="Deva" typeface="Mangal"/>
+        <a:font script="Telu" typeface="Gautami"/>
+        <a:font script="Taml" typeface="Latha"/>
+        <a:font script="Syrc" typeface="Estrangelo Edessa"/>
+        <a:font script="Orya" typeface="Kalinga"/>
+        <a:font script="Mlym" typeface="Kartika"/>
+        <a:font script="Laoo" typeface="DokChampa"/>
+        <a:font script="Sinh" typeface="Iskoola Pota"/>
+        <a:font script="Mong" typeface="Mongolian Baiti"/>
+        <a:font script="Viet" typeface="Times New Roman"/>
+        <a:font script="Uigh" typeface="Microsoft Uighur"/>
+        <a:font script="Geor" typeface="Sylfaen"/>
+      </a:majorFont>
+      <a:minorFont>
+        <a:latin typeface="Tahoma"/>
+        <a:ea typeface="Microsoft YaHei"/>
+        <a:cs typeface="Tahoma"/>
+        <a:font script="Jpan" typeface="Microsoft YaHei"/>
+        <a:font script="Hang" typeface="Microsoft YaHei"/>
+        <a:font script="Hans" typeface="Microsoft YaHei"/>
+        <a:font script="Hant" typeface="Microsoft YaHei"/>
+        <a:font script="Arab" typeface="Arial"/>
+        <a:font script="Hebr" typeface="Arial"/>
+        <a:font script="Thai" typeface="Cordia New"/>
+        <a:font script="Ethi" typeface="Nyala"/>
+        <a:font script="Beng" typeface="Vrinda"/>
+        <a:font script="Gujr" typeface="Shruti"/>
+        <a:font script="Khmr" typeface="DaunPenh"/>
+        <a:font script="Knda" typeface="Tunga"/>
+        <a:font script="Guru" typeface="Raavi"/>
+        <a:font script="Cans" typeface="Euphemia"/>
+        <a:font script="Cher" typeface="Plantagenet Cherokee"/>
+        <a:font script="Yiii" typeface="Microsoft Yi Baiti"/>
+        <a:font script="Tibt" typeface="Microsoft Himalaya"/>
+        <a:font script="Thaa" typeface="MV Boli"/>
+        <a:font script="Deva" typeface="Mangal"/>
+        <a:font script="Telu" typeface="Gautami"/>
+        <a:font script="Taml" typeface="Latha"/>
+        <a:font script="Syrc" typeface="Estrangelo Edessa"/>
+        <a:font script="Orya" typeface="Kalinga"/>
+        <a:font script="Mlym" typeface="Kartika"/>
+        <a:font script="Laoo" typeface="DokChampa"/>
+        <a:font script="Sinh" typeface="Iskoola Pota"/>
+        <a:font script="Mong" typeface="Mongolian Baiti"/>
+        <a:font script="Viet" typeface="Arial"/>
+        <a:font script="Uigh" typeface="Microsoft Uighur"/>
+        <a:font script="Geor" typeface="Sylfaen"/>
+      </a:minorFont>
+    </a:fontScheme>
+    <a:fmtScheme name="axiom_pmo_overview">
+      <a:fillStyleLst>
+        <a:solidFill>
+          <a:schemeClr val="phClr"/>
+        </a:solidFill>
+        <a:gradFill rotWithShape="1">
+          <a:gsLst>
+            <a:gs pos="0">
+              <a:schemeClr val="phClr">
+                <a:tint val="50000"/>
+                <a:satMod val="300000"/>
+              </a:schemeClr>
+            </a:gs>
+            <a:gs pos="35000">
+              <a:schemeClr val="phClr">
+                <a:tint val="37000"/>
+                <a:satMod val="300000"/>
+              </a:schemeClr>
+            </a:gs>
+            <a:gs pos="100000">
+              <a:schemeClr val="phClr">
+                <a:tint val="15000"/>
+                <a:satMod val="350000"/>
+              </a:schemeClr>
+            </a:gs>
+          </a:gsLst>
+          <a:lin ang="16200000" scaled="1"/>
+        </a:gradFill>
+        <a:gradFill rotWithShape="1">
+          <a:gsLst>
+            <a:gs pos="0">
+              <a:schemeClr val="phClr">
+                <a:tint val="100000"/>
+                <a:shade val="100000"/>
+                <a:satMod val="130000"/>
+              </a:schemeClr>
+            </a:gs>
+            <a:gs pos="100000">
+              <a:schemeClr val="phClr">
+                <a:tint val="50000"/>
+                <a:shade val="100000"/>
+                <a:satMod val="350000"/>
+              </a:schemeClr>
+            </a:gs>
+          </a:gsLst>
+          <a:lin ang="16200000" scaled="0"/>
+        </a:gradFill>
+      </a:fillStyleLst>
+      <a:lnStyleLst>
+        <a:ln w="9525" cap="flat" cmpd="sng" algn="ctr">
+          <a:solidFill>
+            <a:schemeClr val="phClr">
+              <a:shade val="95000"/>
+              <a:satMod val="105000"/>
+            </a:schemeClr>
+          </a:solidFill>
+          <a:prstDash val="solid"/>
+        </a:ln>
+        <a:ln w="25400" cap="flat" cmpd="sng" algn="ctr">
+          <a:solidFill>
+            <a:schemeClr val="phClr"/>
+          </a:solidFill>
+          <a:prstDash val="solid"/>
+        </a:ln>
+        <a:ln w="38100" cap="flat" cmpd="sng" algn="ctr">
+          <a:solidFill>
+            <a:schemeClr val="phClr"/>
+          </a:solidFill>
+          <a:prstDash val="solid"/>
+        </a:ln>
+      </a:lnStyleLst>
+      <a:effectStyleLst>
+        <a:effectStyle>
+          <a:effectLst>
+            <a:outerShdw blurRad="40000" dist="20000" dir="5400000" rotWithShape="0">
+              <a:srgbClr val="000000">
+                <a:alpha val="38000"/>
+              </a:srgbClr>
+            </a:outerShdw>
+          </a:effectLst>
+        </a:effectStyle>
+        <a:effectStyle>
+          <a:effectLst>
+            <a:outerShdw blurRad="40000" dist="23000" dir="5400000" rotWithShape="0">
+              <a:srgbClr val="000000">
+                <a:alpha val="35000"/>
+              </a:srgbClr>
+            </a:outerShdw>
+          </a:effectLst>
+        </a:effectStyle>
+        <a:effectStyle>
+          <a:effectLst>
+            <a:outerShdw blurRad="40000" dist="23000" dir="5400000" rotWithShape="0">
+              <a:srgbClr val="000000">
+                <a:alpha val="35000"/>
+              </a:srgbClr>
+            </a:outerShdw>
+          </a:effectLst>
+          <a:scene3d>
+            <a:camera prst="orthographicFront">
+              <a:rot lat="0" lon="0" rev="0"/>
+            </a:camera>
+            <a:lightRig rig="threePt" dir="t">
+              <a:rot lat="0" lon="0" rev="1200000"/>
+            </a:lightRig>
+          </a:scene3d>
+          <a:sp3d>
+            <a:bevelT w="63500" h="25400"/>
+          </a:sp3d>
+        </a:effectStyle>
+      </a:effectStyleLst>
+      <a:bgFillStyleLst>
+        <a:solidFill>
+          <a:schemeClr val="phClr"/>
+        </a:solidFill>
+        <a:gradFill rotWithShape="1">
+          <a:gsLst>
+            <a:gs pos="0">
+              <a:schemeClr val="phClr">
+                <a:tint val="40000"/>
+                <a:satMod val="350000"/>
+              </a:schemeClr>
+            </a:gs>
+            <a:gs pos="40000">
+              <a:schemeClr val="phClr">
+                <a:tint val="45000"/>
+                <a:shade val="99000"/>
+                <a:satMod val="350000"/>
+              </a:schemeClr>
+            </a:gs>
+            <a:gs pos="100000">
+              <a:schemeClr val="phClr">
+                <a:shade val="20000"/>
+                <a:satMod val="255000"/>
+              </a:schemeClr>
+            </a:gs>
+          </a:gsLst>
+          <a:path path="circle">
+            <a:fillToRect l="50000" t="-80000" r="50000" b="180000"/>
+          </a:path>
+        </a:gradFill>
+        <a:gradFill rotWithShape="1">
+          <a:gsLst>
+            <a:gs pos="0">
+              <a:schemeClr val="phClr">
+                <a:tint val="80000"/>
+                <a:satMod val="300000"/>
+              </a:schemeClr>
+            </a:gs>
+            <a:gs pos="100000">
+              <a:schemeClr val="phClr">
+                <a:shade val="30000"/>
+                <a:satMod val="200000"/>
+              </a:schemeClr>
+            </a:gs>
+          </a:gsLst>
+          <a:path path="circle">
+            <a:fillToRect l="50000" t="50000" r="50000" b="50000"/>
+          </a:path>
+        </a:gradFill>
+      </a:bgFillStyleLst>
+    </a:fmtScheme>
+  </a:themeElements>
+  <a:objectDefaults>
+    <a:spDef>
+      <a:spPr/>
+      <a:bodyPr/>
+      <a:lstStyle/>
+      <a:style>
+        <a:lnRef idx="1">
+          <a:schemeClr val="accent1"/>
+        </a:lnRef>
+        <a:fillRef idx="3">
+          <a:schemeClr val="accent1"/>
+        </a:fillRef>
+        <a:effectRef idx="2">
+          <a:schemeClr val="accent1"/>
+        </a:effectRef>
+        <a:fontRef idx="minor">
+          <a:schemeClr val="lt1"/>
+        </a:fontRef>
+      </a:style>
+    </a:spDef>
+    <a:lnDef>
+      <a:spPr/>
+      <a:bodyPr/>
+      <a:lstStyle/>
+      <a:style>
+        <a:lnRef idx="2">
+          <a:schemeClr val="accent1"/>
+        </a:lnRef>
+        <a:fillRef idx="0">
+          <a:schemeClr val="accent1"/>
+        </a:fillRef>
+        <a:effectRef idx="1">
+          <a:schemeClr val="accent1"/>
+        </a:effectRef>
+        <a:fontRef idx="minor">
+          <a:schemeClr val="tx1"/>
+        </a:fontRef>
+      </a:style>
+    </a:lnDef>
+  </a:objectDefaults>
+  <a:extraClrSchemeLst/>
+</a:theme>
 </file>
</xml_diff>